<commit_message>
Split US and Singapore into dedicated slides; add Singapore clients
Co-Authored-By: Claude Opus 5.5 <noreply@anthropic.com>
Claude-Session: https://claude.ai/code/session_0163hpKmxzgxik6N8WufbS7q
</commit_message>
<xml_diff>
--- a/Lotus BPO - Conference Deck.pptx
+++ b/Lotus BPO - Conference Deck.pptx
@@ -19,9 +19,10 @@
     <p:sldId id="267" r:id="rId13"/>
     <p:sldId id="268" r:id="rId14"/>
     <p:sldId id="269" r:id="rId15"/>
+    <p:sldId id="270" r:id="rId16"/>
   </p:sldIdLst>
   <p:notesMasterIdLst>
-    <p:notesMasterId r:id="rId16"/>
+    <p:notesMasterId r:id="rId17"/>
   </p:notesMasterIdLst>
   <p:sldSz cx="12192000" cy="6858000"/>
   <p:notesSz cx="6858000" cy="12192000"/>
@@ -120,50 +121,55 @@
   <p:extLst>
     <p:ext uri="{521415D9-36F7-43E2-AB2F-B90AF26B5E84}">
       <p14:sectionLst xmlns:p14="http://schemas.microsoft.com/office/powerpoint/2010/main">
-        <p14:section name="Welcome" id="{5fbc1006-218f-ca62-21fd-43f33c05481b}">
+        <p14:section name="Welcome" id="{927557c4-beb5-ccc3-499c-f34e9c2626d8}">
           <p14:sldIdLst>
             <p14:sldId id="256"/>
           </p14:sldIdLst>
         </p14:section>
-        <p14:section name="About Us" id="{c19cf67c-3123-a286-5344-0a6e7c200470}">
+        <p14:section name="About Us" id="{9b16161f-2b34-1e6d-373e-e0ae5f2072bd}">
           <p14:sldIdLst>
             <p14:sldId id="257"/>
           </p14:sldIdLst>
         </p14:section>
-        <p14:section name="Our Services" id="{d362c617-6b9b-3ab9-c323-56db4f61edd4}">
+        <p14:section name="Our Services" id="{010cf3fb-7f2d-01e0-2553-cca5a2feb0aa}">
           <p14:sldIdLst>
             <p14:sldId id="258"/>
             <p14:sldId id="259"/>
             <p14:sldId id="260"/>
           </p14:sldIdLst>
         </p14:section>
-        <p14:section name="Canada" id="{f2b0ee7a-1321-2ea7-f479-796cca66e4b5}">
+        <p14:section name="Canada" id="{24d1364f-aec5-8dc0-757b-77efb5ea5c7d}">
           <p14:sldIdLst>
             <p14:sldId id="261"/>
             <p14:sldId id="262"/>
           </p14:sldIdLst>
         </p14:section>
-        <p14:section name="Australia" id="{69f4404f-89d9-8a31-625a-46fc7909458f}">
+        <p14:section name="Australia" id="{2ad1071b-9261-6aaa-5823-e9f74e9dfba3}">
           <p14:sldIdLst>
             <p14:sldId id="263"/>
           </p14:sldIdLst>
         </p14:section>
-        <p14:section name="US &amp; Singapore" id="{123ea112-fad4-4063-6d57-fe01b6352ed6}">
+        <p14:section name="United States" id="{27fcb0f6-da6d-f7dd-eefe-e8c5db7fff3e}">
           <p14:sldIdLst>
             <p14:sldId id="264"/>
           </p14:sldIdLst>
         </p14:section>
-        <p14:section name="Working Together" id="{b47f8e36-b346-be7b-609d-476345a9d917}">
+        <p14:section name="Singapore" id="{84aedca5-43bd-33c6-5648-95ab04384272}">
           <p14:sldIdLst>
             <p14:sldId id="265"/>
+          </p14:sldIdLst>
+        </p14:section>
+        <p14:section name="Working Together" id="{f226a0dc-1632-2113-1455-8bc953cb90a2}">
+          <p14:sldIdLst>
             <p14:sldId id="266"/>
             <p14:sldId id="267"/>
+            <p14:sldId id="268"/>
           </p14:sldIdLst>
         </p14:section>
-        <p14:section name="Next Steps" id="{3e0e9051-96f3-8e27-27fe-05e4a4286e5d}">
+        <p14:section name="Next Steps" id="{e3826a5e-a194-c6f3-2ae2-bb38bf5f466b}">
           <p14:sldIdLst>
-            <p14:sldId id="268"/>
             <p14:sldId id="269"/>
+            <p14:sldId id="270"/>
           </p14:sldIdLst>
         </p14:section>
       </p14:sectionLst>
@@ -658,7 +664,7 @@
           <a:p>
             <a:r>
               <a:rPr lang="en-US" dirty="0"/>
-              <a:t>We want to be fully transparent about our role. When we work through an accounting firm, we prepare the tax reports and the firm reviews and submits them. With Opty, we prepare the T2 in their CCH iFirm and Opty files it. With Harry Chang, we prepare an Excel T2 workbook and they file it in their own system. With Stone Group, we prepare the BAS in Xero and Stone Group lodges it. The final sign-off always stays with the firm.</a:t>
+              <a:t>In Singapore, we support small and mid-sized businesses. We keep their books in QuickBooks and Xero, maintain clean, reconciled accounts throughout the year, and prepare their annual financial statements, ready for the directors' review and the company's Annual General Meeting. Our clients include Samai Distillery Cambodia, Nurkas Holdings, Qwqer International and Tanncam Investment.</a:t>
             </a:r>
             <a:endParaRPr lang="en-US" dirty="0"/>
           </a:p>
@@ -746,7 +752,7 @@
           <a:p>
             <a:r>
               <a:rPr lang="en-US" dirty="0"/>
-              <a:t>Working with us follows five simple steps. Discover: we learn your needs, systems and deadlines. Onboard: we set up secure access to your files and software. Prepare: our team completes the books and prepares the tax reports. Review: your team checks and approves. Submit: you file from your own system and keep the client relationship. This reflects the theme of this conference, Humans in the Lead: skilled accountants do the work, your team makes the final call, and your clients remain yours.</a:t>
+              <a:t>We want to be fully transparent about our role. When we work through an accounting firm, we prepare the tax reports and the firm reviews and submits them. With Opty, we prepare the T2 in their CCH iFirm and Opty files it. With Harry Chang, we prepare an Excel T2 workbook and they file it in their own system. With Stone Group, we prepare the BAS in Xero and Stone Group lodges it. The final sign-off always stays with the firm.</a:t>
             </a:r>
             <a:endParaRPr lang="en-US" dirty="0"/>
           </a:p>
@@ -834,7 +840,7 @@
           <a:p>
             <a:r>
               <a:rPr lang="en-US" dirty="0"/>
-              <a:t>Why partner with us? Cost efficiency: skilled work at a lower cost than hiring locally. Faster turnaround: thanks to the time difference, work keeps moving while your office is closed. Platform ready: we already work in QuickBooks, Xero, CaseWare and CCH iFirm. Scale on demand: handle busy season without adding headcount. Confidentiality first: your client data is handled with care. And we are proven in four markets.</a:t>
+              <a:t>Working with us follows five simple steps. Discover: we learn your needs, systems and deadlines. Onboard: we set up secure access to your files and software. Prepare: our team completes the books and prepares the tax reports. Review: your team checks and approves. Submit: you file from your own system and keep the client relationship. This reflects the theme of this conference, Humans in the Lead: skilled accountants do the work, your team makes the final call, and your clients remain yours.</a:t>
             </a:r>
             <a:endParaRPr lang="en-US" dirty="0"/>
           </a:p>
@@ -922,7 +928,7 @@
           <a:p>
             <a:r>
               <a:rPr lang="en-US" dirty="0"/>
-              <a:t>So, where do we go from here? Let's talk over coffee during the conference breaks. If it feels like a good fit, start with a pilot of a few client files and see our quality first-hand. Then we grow the scope together as trust and volume build. You can reach us anytime at +84 902 343 218.</a:t>
+              <a:t>Why partner with us? Cost efficiency: skilled work at a lower cost than hiring locally. Faster turnaround: thanks to the time difference, work keeps moving while your office is closed. Platform ready: we already work in QuickBooks, Xero, CaseWare and CCH iFirm. Scale on demand: handle busy season without adding headcount. Confidentiality first: your client data is handled with care. And we are proven in four markets.</a:t>
             </a:r>
             <a:endParaRPr lang="en-US" dirty="0"/>
           </a:p>
@@ -1010,7 +1016,7 @@
           <a:p>
             <a:r>
               <a:rPr lang="en-US" dirty="0"/>
-              <a:t>Thank you for your time and attention. I would be glad to take any questions, here or during the breaks.</a:t>
+              <a:t>So, where do we go from here? Let's talk over coffee during the conference breaks. If it feels like a good fit, start with a pilot of a few client files and see our quality first-hand. Then we grow the scope together as trust and volume build. You can reach us anytime at +84 902 343 218.</a:t>
             </a:r>
             <a:endParaRPr lang="en-US" dirty="0"/>
           </a:p>
@@ -1034,6 +1040,94 @@
             <a:fld id="{F7021451-1387-4CA6-816F-3879F97B5CBC}" type="slidenum">
               <a:rPr lang="en-US"/>
               <a:t>14</a:t>
+            </a:fld>
+            <a:endParaRPr lang="en-US"/>
+          </a:p>
+        </p:txBody>
+      </p:sp>
+    </p:spTree>
+    <p:extLst>
+      <p:ext uri="{BB962C8B-B14F-4D97-AF65-F5344CB8AC3E}">
+        <p14:creationId xmlns:p14="http://schemas.microsoft.com/office/powerpoint/2010/main" val="1024086991"/>
+      </p:ext>
+    </p:extLst>
+  </p:cSld>
+  <p:clrMapOvr>
+    <a:masterClrMapping/>
+  </p:clrMapOvr>
+</p:notes>
+</file>
+
+<file path=ppt/notesSlides/notesSlide15.xml><?xml version="1.0" encoding="utf-8"?>
+<p:notes xmlns:a="http://schemas.openxmlformats.org/drawingml/2006/main" xmlns:r="http://schemas.openxmlformats.org/officeDocument/2006/relationships" xmlns:p="http://schemas.openxmlformats.org/presentationml/2006/main">
+  <p:cSld>
+    <p:spTree>
+      <p:nvGrpSpPr>
+        <p:cNvPr id="1" name=""/>
+        <p:cNvGrpSpPr/>
+        <p:nvPr/>
+      </p:nvGrpSpPr>
+      <p:grpSpPr>
+        <a:xfrm>
+          <a:off x="0" y="0"/>
+          <a:ext cx="0" cy="0"/>
+          <a:chOff x="0" y="0"/>
+          <a:chExt cx="0" cy="0"/>
+        </a:xfrm>
+      </p:grpSpPr>
+      <p:sp>
+        <p:nvSpPr>
+          <p:cNvPr id="2" name="Slide Image Placeholder 1"/>
+          <p:cNvSpPr>
+            <a:spLocks noGrp="1" noRot="1" noChangeAspect="1"/>
+          </p:cNvSpPr>
+          <p:nvPr>
+            <p:ph type="sldImg"/>
+          </p:nvPr>
+        </p:nvSpPr>
+        <p:spPr/>
+      </p:sp>
+      <p:sp>
+        <p:nvSpPr>
+          <p:cNvPr id="3" name="Notes Placeholder 2"/>
+          <p:cNvSpPr>
+            <a:spLocks noGrp="1"/>
+          </p:cNvSpPr>
+          <p:nvPr>
+            <p:ph type="body" idx="1"/>
+          </p:nvPr>
+        </p:nvSpPr>
+        <p:spPr/>
+        <p:txBody>
+          <a:bodyPr/>
+          <a:lstStyle/>
+          <a:p>
+            <a:r>
+              <a:rPr lang="en-US" dirty="0"/>
+              <a:t>Thank you for your time and attention. I would be glad to take any questions, here or during the breaks.</a:t>
+            </a:r>
+            <a:endParaRPr lang="en-US" dirty="0"/>
+          </a:p>
+        </p:txBody>
+      </p:sp>
+      <p:sp>
+        <p:nvSpPr>
+          <p:cNvPr id="4" name="Slide Number Placeholder 3"/>
+          <p:cNvSpPr>
+            <a:spLocks noGrp="1"/>
+          </p:cNvSpPr>
+          <p:nvPr>
+            <p:ph type="sldNum" sz="quarter" idx="10"/>
+          </p:nvPr>
+        </p:nvSpPr>
+        <p:spPr/>
+        <p:txBody>
+          <a:bodyPr/>
+          <a:lstStyle/>
+          <a:p>
+            <a:fld id="{F7021451-1387-4CA6-816F-3879F97B5CBC}" type="slidenum">
+              <a:rPr lang="en-US"/>
+              <a:t>15</a:t>
             </a:fld>
             <a:endParaRPr lang="en-US"/>
           </a:p>
@@ -1714,7 +1808,7 @@
           <a:p>
             <a:r>
               <a:rPr lang="en-US" dirty="0"/>
-              <a:t>We also serve the United States and Singapore. In the United States, we prepare and file taxes and offer tax and business consulting for small and mid-sized businesses. In Singapore, we keep SMEs' books in QuickBooks and Xero and prepare their annual financial statements, ready for the directors' review and the company's Annual General Meeting. It is the same team and the same standards in every market we serve.</a:t>
+              <a:t>In the United States, we work with small and mid-sized businesses. We prepare and file their tax returns, and we provide tax and business consulting to help owners make sound decisions. Our clients get one dedicated team, clear answers in plain language, and deadlines that are tracked and met.</a:t>
             </a:r>
             <a:endParaRPr lang="en-US" dirty="0"/>
           </a:p>
@@ -2810,6 +2904,1684 @@
                   <a:schemeClr val="tx2"/>
                 </a:solidFill>
               </a:rPr>
+              <a:t>Singapore</a:t>
+            </a:r>
+            <a:endParaRPr lang="en-US" sz="3600" dirty="0"/>
+          </a:p>
+        </p:txBody>
+      </p:sp>
+      <p:sp>
+        <p:nvSpPr>
+          <p:cNvPr id="3" name="a1-sub"/>
+          <p:cNvSpPr txBox="1"/>
+          <p:nvPr/>
+        </p:nvSpPr>
+        <p:spPr>
+          <a:xfrm>
+            <a:off x="548640" y="1143000"/>
+            <a:ext cx="5852160" cy="411480"/>
+          </a:xfrm>
+          <a:prstGeom prst="rect">
+            <a:avLst/>
+          </a:prstGeom>
+          <a:noFill/>
+          <a:ln/>
+        </p:spPr>
+        <p:txBody>
+          <a:bodyPr wrap="square" lIns="0" tIns="0" rIns="0" bIns="0" rtlCol="0" anchor="ctr"/>
+          <a:lstStyle/>
+          <a:p>
+            <a:pPr indent="0" marL="0">
+              <a:buNone/>
+            </a:pPr>
+            <a:r>
+              <a:rPr lang="en-US" sz="1800" dirty="0">
+                <a:solidFill>
+                  <a:schemeClr val="accent5"/>
+                </a:solidFill>
+              </a:rPr>
+              <a:t>Accounting and reporting for small and mid-sized businesses</a:t>
+            </a:r>
+            <a:endParaRPr lang="en-US" sz="1800" dirty="0"/>
+          </a:p>
+        </p:txBody>
+      </p:sp>
+      <p:sp>
+        <p:nvSpPr>
+          <p:cNvPr id="4" name="a2-d"/>
+          <p:cNvSpPr/>
+          <p:nvPr/>
+        </p:nvSpPr>
+        <p:spPr>
+          <a:xfrm>
+            <a:off x="548640" y="1874520"/>
+            <a:ext cx="868680" cy="868680"/>
+          </a:xfrm>
+          <a:prstGeom prst="ellipse">
+            <a:avLst/>
+          </a:prstGeom>
+          <a:solidFill>
+            <a:schemeClr val="tx2"/>
+          </a:solidFill>
+          <a:ln/>
+        </p:spPr>
+      </p:sp>
+      <p:pic>
+        <p:nvPicPr>
+          <p:cNvPr id="5" name="a2-d-i" descr="preencoded.png">    </p:cNvPr>
+          <p:cNvPicPr>
+            <a:picLocks noChangeAspect="1"/>
+          </p:cNvPicPr>
+          <p:nvPr/>
+        </p:nvPicPr>
+        <p:blipFill>
+          <a:blip r:embed="rId1"/>
+          <a:stretch>
+            <a:fillRect/>
+          </a:stretch>
+        </p:blipFill>
+        <p:spPr>
+          <a:xfrm>
+            <a:off x="765810" y="2091690"/>
+            <a:ext cx="434340" cy="434340"/>
+          </a:xfrm>
+          <a:prstGeom prst="rect">
+            <a:avLst/>
+          </a:prstGeom>
+        </p:spPr>
+      </p:pic>
+      <p:sp>
+        <p:nvSpPr>
+          <p:cNvPr id="6" name="a2-t"/>
+          <p:cNvSpPr txBox="1"/>
+          <p:nvPr/>
+        </p:nvSpPr>
+        <p:spPr>
+          <a:xfrm>
+            <a:off x="1645920" y="1828800"/>
+            <a:ext cx="4663440" cy="960120"/>
+          </a:xfrm>
+          <a:prstGeom prst="rect">
+            <a:avLst/>
+          </a:prstGeom>
+          <a:noFill/>
+          <a:ln/>
+        </p:spPr>
+        <p:txBody>
+          <a:bodyPr wrap="square" lIns="0" tIns="0" rIns="0" bIns="0" rtlCol="0" anchor="ctr"/>
+          <a:lstStyle/>
+          <a:p>
+            <a:pPr indent="0" marL="0">
+              <a:buNone/>
+            </a:pPr>
+            <a:r>
+              <a:rPr lang="en-US" sz="2000" b="1" dirty="0">
+                <a:solidFill>
+                  <a:schemeClr val="tx2"/>
+                </a:solidFill>
+              </a:rPr>
+              <a:t>Bookkeeping in QuickBooks &amp; Xero</a:t>
+            </a:r>
+            <a:endParaRPr lang="en-US" sz="2000" dirty="0"/>
+          </a:p>
+          <a:p>
+            <a:pPr indent="0" marL="0">
+              <a:buNone/>
+            </a:pPr>
+            <a:r>
+              <a:rPr lang="en-US" sz="1500" dirty="0">
+                <a:solidFill>
+                  <a:schemeClr val="accent5"/>
+                </a:solidFill>
+              </a:rPr>
+              <a:t>Books kept accurate and up to date</a:t>
+            </a:r>
+            <a:endParaRPr lang="en-US" sz="2000" dirty="0"/>
+          </a:p>
+        </p:txBody>
+      </p:sp>
+      <p:sp>
+        <p:nvSpPr>
+          <p:cNvPr id="7" name="a3-d"/>
+          <p:cNvSpPr/>
+          <p:nvPr/>
+        </p:nvSpPr>
+        <p:spPr>
+          <a:xfrm>
+            <a:off x="548640" y="3200400"/>
+            <a:ext cx="868680" cy="868680"/>
+          </a:xfrm>
+          <a:prstGeom prst="ellipse">
+            <a:avLst/>
+          </a:prstGeom>
+          <a:solidFill>
+            <a:schemeClr val="tx2"/>
+          </a:solidFill>
+          <a:ln/>
+        </p:spPr>
+      </p:sp>
+      <p:pic>
+        <p:nvPicPr>
+          <p:cNvPr id="8" name="a3-d-i" descr="preencoded.png">    </p:cNvPr>
+          <p:cNvPicPr>
+            <a:picLocks noChangeAspect="1"/>
+          </p:cNvPicPr>
+          <p:nvPr/>
+        </p:nvPicPr>
+        <p:blipFill>
+          <a:blip r:embed="rId2"/>
+          <a:stretch>
+            <a:fillRect/>
+          </a:stretch>
+        </p:blipFill>
+        <p:spPr>
+          <a:xfrm>
+            <a:off x="765810" y="3417570"/>
+            <a:ext cx="434340" cy="434340"/>
+          </a:xfrm>
+          <a:prstGeom prst="rect">
+            <a:avLst/>
+          </a:prstGeom>
+        </p:spPr>
+      </p:pic>
+      <p:sp>
+        <p:nvSpPr>
+          <p:cNvPr id="9" name="a3-t"/>
+          <p:cNvSpPr txBox="1"/>
+          <p:nvPr/>
+        </p:nvSpPr>
+        <p:spPr>
+          <a:xfrm>
+            <a:off x="1645920" y="3154680"/>
+            <a:ext cx="4663440" cy="960120"/>
+          </a:xfrm>
+          <a:prstGeom prst="rect">
+            <a:avLst/>
+          </a:prstGeom>
+          <a:noFill/>
+          <a:ln/>
+        </p:spPr>
+        <p:txBody>
+          <a:bodyPr wrap="square" lIns="0" tIns="0" rIns="0" bIns="0" rtlCol="0" anchor="ctr"/>
+          <a:lstStyle/>
+          <a:p>
+            <a:pPr indent="0" marL="0">
+              <a:buNone/>
+            </a:pPr>
+            <a:r>
+              <a:rPr lang="en-US" sz="2000" b="1" dirty="0">
+                <a:solidFill>
+                  <a:schemeClr val="tx2"/>
+                </a:solidFill>
+              </a:rPr>
+              <a:t>Accounting &amp; Records</a:t>
+            </a:r>
+            <a:endParaRPr lang="en-US" sz="2000" dirty="0"/>
+          </a:p>
+          <a:p>
+            <a:pPr indent="0" marL="0">
+              <a:buNone/>
+            </a:pPr>
+            <a:r>
+              <a:rPr lang="en-US" sz="1500" dirty="0">
+                <a:solidFill>
+                  <a:schemeClr val="accent5"/>
+                </a:solidFill>
+              </a:rPr>
+              <a:t>Clean, reconciled accounts all year round</a:t>
+            </a:r>
+            <a:endParaRPr lang="en-US" sz="2000" dirty="0"/>
+          </a:p>
+        </p:txBody>
+      </p:sp>
+      <p:sp>
+        <p:nvSpPr>
+          <p:cNvPr id="10" name="a4-d"/>
+          <p:cNvSpPr/>
+          <p:nvPr/>
+        </p:nvSpPr>
+        <p:spPr>
+          <a:xfrm>
+            <a:off x="548640" y="4526280"/>
+            <a:ext cx="868680" cy="868680"/>
+          </a:xfrm>
+          <a:prstGeom prst="ellipse">
+            <a:avLst/>
+          </a:prstGeom>
+          <a:solidFill>
+            <a:schemeClr val="accent1"/>
+          </a:solidFill>
+          <a:ln/>
+        </p:spPr>
+      </p:sp>
+      <p:pic>
+        <p:nvPicPr>
+          <p:cNvPr id="11" name="a4-d-i" descr="preencoded.png">    </p:cNvPr>
+          <p:cNvPicPr>
+            <a:picLocks noChangeAspect="1"/>
+          </p:cNvPicPr>
+          <p:nvPr/>
+        </p:nvPicPr>
+        <p:blipFill>
+          <a:blip r:embed="rId3"/>
+          <a:stretch>
+            <a:fillRect/>
+          </a:stretch>
+        </p:blipFill>
+        <p:spPr>
+          <a:xfrm>
+            <a:off x="765810" y="4743450"/>
+            <a:ext cx="434340" cy="434340"/>
+          </a:xfrm>
+          <a:prstGeom prst="rect">
+            <a:avLst/>
+          </a:prstGeom>
+        </p:spPr>
+      </p:pic>
+      <p:sp>
+        <p:nvSpPr>
+          <p:cNvPr id="12" name="a4-t"/>
+          <p:cNvSpPr txBox="1"/>
+          <p:nvPr/>
+        </p:nvSpPr>
+        <p:spPr>
+          <a:xfrm>
+            <a:off x="1645920" y="4480560"/>
+            <a:ext cx="4663440" cy="960120"/>
+          </a:xfrm>
+          <a:prstGeom prst="rect">
+            <a:avLst/>
+          </a:prstGeom>
+          <a:noFill/>
+          <a:ln/>
+        </p:spPr>
+        <p:txBody>
+          <a:bodyPr wrap="square" lIns="0" tIns="0" rIns="0" bIns="0" rtlCol="0" anchor="ctr"/>
+          <a:lstStyle/>
+          <a:p>
+            <a:pPr indent="0" marL="0">
+              <a:buNone/>
+            </a:pPr>
+            <a:r>
+              <a:rPr lang="en-US" sz="2000" b="1" dirty="0">
+                <a:solidFill>
+                  <a:schemeClr val="tx2"/>
+                </a:solidFill>
+              </a:rPr>
+              <a:t>Annual Financial Statements</a:t>
+            </a:r>
+            <a:endParaRPr lang="en-US" sz="2000" dirty="0"/>
+          </a:p>
+          <a:p>
+            <a:pPr indent="0" marL="0">
+              <a:buNone/>
+            </a:pPr>
+            <a:r>
+              <a:rPr lang="en-US" sz="1500" dirty="0">
+                <a:solidFill>
+                  <a:schemeClr val="accent5"/>
+                </a:solidFill>
+              </a:rPr>
+              <a:t>Prepared for directors' review and the AGM</a:t>
+            </a:r>
+            <a:endParaRPr lang="en-US" sz="2000" dirty="0"/>
+          </a:p>
+        </p:txBody>
+      </p:sp>
+      <p:sp>
+        <p:nvSpPr>
+          <p:cNvPr id="13" name="a5-p"/>
+          <p:cNvSpPr/>
+          <p:nvPr/>
+        </p:nvSpPr>
+        <p:spPr>
+          <a:xfrm>
+            <a:off x="6583680" y="1417320"/>
+            <a:ext cx="5029200" cy="4626864"/>
+          </a:xfrm>
+          <a:prstGeom prst="roundRect">
+            <a:avLst>
+              <a:gd name="adj" fmla="val 2372"/>
+            </a:avLst>
+          </a:prstGeom>
+          <a:solidFill>
+            <a:schemeClr val="tx2"/>
+          </a:solidFill>
+          <a:ln/>
+        </p:spPr>
+      </p:sp>
+      <p:sp>
+        <p:nvSpPr>
+          <p:cNvPr id="14" name="a5-h"/>
+          <p:cNvSpPr txBox="1"/>
+          <p:nvPr/>
+        </p:nvSpPr>
+        <p:spPr>
+          <a:xfrm>
+            <a:off x="6949440" y="1691640"/>
+            <a:ext cx="4389120" cy="320040"/>
+          </a:xfrm>
+          <a:prstGeom prst="rect">
+            <a:avLst/>
+          </a:prstGeom>
+          <a:noFill/>
+          <a:ln/>
+        </p:spPr>
+        <p:txBody>
+          <a:bodyPr wrap="square" lIns="0" tIns="0" rIns="0" bIns="0" rtlCol="0" anchor="ctr"/>
+          <a:lstStyle/>
+          <a:p>
+            <a:pPr indent="0" marL="0">
+              <a:buNone/>
+            </a:pPr>
+            <a:r>
+              <a:rPr lang="en-US" sz="1300" b="1" spc="200" kern="0" dirty="0">
+                <a:solidFill>
+                  <a:schemeClr val="accent3"/>
+                </a:solidFill>
+              </a:rPr>
+              <a:t>WHO WE SERVE</a:t>
+            </a:r>
+            <a:endParaRPr lang="en-US" sz="1300" dirty="0"/>
+          </a:p>
+        </p:txBody>
+      </p:sp>
+      <p:sp>
+        <p:nvSpPr>
+          <p:cNvPr id="15" name="a5-t"/>
+          <p:cNvSpPr txBox="1"/>
+          <p:nvPr/>
+        </p:nvSpPr>
+        <p:spPr>
+          <a:xfrm>
+            <a:off x="6949440" y="2011680"/>
+            <a:ext cx="4389120" cy="365760"/>
+          </a:xfrm>
+          <a:prstGeom prst="rect">
+            <a:avLst/>
+          </a:prstGeom>
+          <a:noFill/>
+          <a:ln/>
+        </p:spPr>
+        <p:txBody>
+          <a:bodyPr wrap="square" lIns="0" tIns="0" rIns="0" bIns="0" rtlCol="0" anchor="ctr"/>
+          <a:lstStyle/>
+          <a:p>
+            <a:pPr indent="0" marL="0">
+              <a:buNone/>
+            </a:pPr>
+            <a:r>
+              <a:rPr lang="en-US" sz="1700" b="1" dirty="0">
+                <a:solidFill>
+                  <a:schemeClr val="bg1"/>
+                </a:solidFill>
+              </a:rPr>
+              <a:t>Small &amp; mid-sized businesses (SMEs)</a:t>
+            </a:r>
+            <a:endParaRPr lang="en-US" sz="1700" dirty="0"/>
+          </a:p>
+        </p:txBody>
+      </p:sp>
+      <p:sp>
+        <p:nvSpPr>
+          <p:cNvPr id="16" name="a6-h"/>
+          <p:cNvSpPr txBox="1"/>
+          <p:nvPr/>
+        </p:nvSpPr>
+        <p:spPr>
+          <a:xfrm>
+            <a:off x="6949440" y="2606040"/>
+            <a:ext cx="4389120" cy="320040"/>
+          </a:xfrm>
+          <a:prstGeom prst="rect">
+            <a:avLst/>
+          </a:prstGeom>
+          <a:noFill/>
+          <a:ln/>
+        </p:spPr>
+        <p:txBody>
+          <a:bodyPr wrap="square" lIns="0" tIns="0" rIns="0" bIns="0" rtlCol="0" anchor="ctr"/>
+          <a:lstStyle/>
+          <a:p>
+            <a:pPr indent="0" marL="0">
+              <a:buNone/>
+            </a:pPr>
+            <a:r>
+              <a:rPr lang="en-US" sz="1300" b="1" spc="200" kern="0" dirty="0">
+                <a:solidFill>
+                  <a:schemeClr val="accent3"/>
+                </a:solidFill>
+              </a:rPr>
+              <a:t>SELECTED CLIENTS</a:t>
+            </a:r>
+            <a:endParaRPr lang="en-US" sz="1300" dirty="0"/>
+          </a:p>
+        </p:txBody>
+      </p:sp>
+      <p:sp>
+        <p:nvSpPr>
+          <p:cNvPr id="17" name="a6-c0"/>
+          <p:cNvSpPr/>
+          <p:nvPr/>
+        </p:nvSpPr>
+        <p:spPr>
+          <a:xfrm>
+            <a:off x="6949440" y="2971800"/>
+            <a:ext cx="4297680" cy="603504"/>
+          </a:xfrm>
+          <a:prstGeom prst="roundRect">
+            <a:avLst>
+              <a:gd name="adj" fmla="val 18182"/>
+            </a:avLst>
+          </a:prstGeom>
+          <a:solidFill>
+            <a:schemeClr val="bg1"/>
+          </a:solidFill>
+          <a:ln/>
+        </p:spPr>
+      </p:sp>
+      <p:sp>
+        <p:nvSpPr>
+          <p:cNvPr id="18" name="a6-n0"/>
+          <p:cNvSpPr txBox="1"/>
+          <p:nvPr/>
+        </p:nvSpPr>
+        <p:spPr>
+          <a:xfrm>
+            <a:off x="7178040" y="2971800"/>
+            <a:ext cx="3931920" cy="603504"/>
+          </a:xfrm>
+          <a:prstGeom prst="rect">
+            <a:avLst/>
+          </a:prstGeom>
+          <a:noFill/>
+          <a:ln/>
+        </p:spPr>
+        <p:txBody>
+          <a:bodyPr wrap="square" lIns="0" tIns="0" rIns="0" bIns="0" rtlCol="0" anchor="ctr"/>
+          <a:lstStyle/>
+          <a:p>
+            <a:pPr indent="0" marL="0">
+              <a:buNone/>
+            </a:pPr>
+            <a:r>
+              <a:rPr lang="en-US" sz="1500" b="1" dirty="0">
+                <a:solidFill>
+                  <a:schemeClr val="tx2"/>
+                </a:solidFill>
+              </a:rPr>
+              <a:t>Samai Distillery Cambodia Pte., Ltd.</a:t>
+            </a:r>
+            <a:endParaRPr lang="en-US" sz="1500" dirty="0"/>
+          </a:p>
+        </p:txBody>
+      </p:sp>
+      <p:sp>
+        <p:nvSpPr>
+          <p:cNvPr id="19" name="a6-c1"/>
+          <p:cNvSpPr/>
+          <p:nvPr/>
+        </p:nvSpPr>
+        <p:spPr>
+          <a:xfrm>
+            <a:off x="6949440" y="3703320"/>
+            <a:ext cx="4297680" cy="603504"/>
+          </a:xfrm>
+          <a:prstGeom prst="roundRect">
+            <a:avLst>
+              <a:gd name="adj" fmla="val 18182"/>
+            </a:avLst>
+          </a:prstGeom>
+          <a:solidFill>
+            <a:schemeClr val="bg1"/>
+          </a:solidFill>
+          <a:ln/>
+        </p:spPr>
+      </p:sp>
+      <p:sp>
+        <p:nvSpPr>
+          <p:cNvPr id="20" name="a6-n1"/>
+          <p:cNvSpPr txBox="1"/>
+          <p:nvPr/>
+        </p:nvSpPr>
+        <p:spPr>
+          <a:xfrm>
+            <a:off x="7178040" y="3703320"/>
+            <a:ext cx="3931920" cy="603504"/>
+          </a:xfrm>
+          <a:prstGeom prst="rect">
+            <a:avLst/>
+          </a:prstGeom>
+          <a:noFill/>
+          <a:ln/>
+        </p:spPr>
+        <p:txBody>
+          <a:bodyPr wrap="square" lIns="0" tIns="0" rIns="0" bIns="0" rtlCol="0" anchor="ctr"/>
+          <a:lstStyle/>
+          <a:p>
+            <a:pPr indent="0" marL="0">
+              <a:buNone/>
+            </a:pPr>
+            <a:r>
+              <a:rPr lang="en-US" sz="1500" b="1" dirty="0">
+                <a:solidFill>
+                  <a:schemeClr val="tx2"/>
+                </a:solidFill>
+              </a:rPr>
+              <a:t>Nurkas Holdings Pte. Ltd.</a:t>
+            </a:r>
+            <a:endParaRPr lang="en-US" sz="1500" dirty="0"/>
+          </a:p>
+        </p:txBody>
+      </p:sp>
+      <p:sp>
+        <p:nvSpPr>
+          <p:cNvPr id="21" name="a6-c2"/>
+          <p:cNvSpPr/>
+          <p:nvPr/>
+        </p:nvSpPr>
+        <p:spPr>
+          <a:xfrm>
+            <a:off x="6949440" y="4434840"/>
+            <a:ext cx="4297680" cy="603504"/>
+          </a:xfrm>
+          <a:prstGeom prst="roundRect">
+            <a:avLst>
+              <a:gd name="adj" fmla="val 18182"/>
+            </a:avLst>
+          </a:prstGeom>
+          <a:solidFill>
+            <a:schemeClr val="bg1"/>
+          </a:solidFill>
+          <a:ln/>
+        </p:spPr>
+      </p:sp>
+      <p:sp>
+        <p:nvSpPr>
+          <p:cNvPr id="22" name="a6-n2"/>
+          <p:cNvSpPr txBox="1"/>
+          <p:nvPr/>
+        </p:nvSpPr>
+        <p:spPr>
+          <a:xfrm>
+            <a:off x="7178040" y="4434840"/>
+            <a:ext cx="3931920" cy="603504"/>
+          </a:xfrm>
+          <a:prstGeom prst="rect">
+            <a:avLst/>
+          </a:prstGeom>
+          <a:noFill/>
+          <a:ln/>
+        </p:spPr>
+        <p:txBody>
+          <a:bodyPr wrap="square" lIns="0" tIns="0" rIns="0" bIns="0" rtlCol="0" anchor="ctr"/>
+          <a:lstStyle/>
+          <a:p>
+            <a:pPr indent="0" marL="0">
+              <a:buNone/>
+            </a:pPr>
+            <a:r>
+              <a:rPr lang="en-US" sz="1500" b="1" dirty="0">
+                <a:solidFill>
+                  <a:schemeClr val="tx2"/>
+                </a:solidFill>
+              </a:rPr>
+              <a:t>Qwqer International Pte. Ltd.</a:t>
+            </a:r>
+            <a:endParaRPr lang="en-US" sz="1500" dirty="0"/>
+          </a:p>
+        </p:txBody>
+      </p:sp>
+      <p:sp>
+        <p:nvSpPr>
+          <p:cNvPr id="23" name="a6-c3"/>
+          <p:cNvSpPr/>
+          <p:nvPr/>
+        </p:nvSpPr>
+        <p:spPr>
+          <a:xfrm>
+            <a:off x="6949440" y="5166360"/>
+            <a:ext cx="4297680" cy="603504"/>
+          </a:xfrm>
+          <a:prstGeom prst="roundRect">
+            <a:avLst>
+              <a:gd name="adj" fmla="val 18182"/>
+            </a:avLst>
+          </a:prstGeom>
+          <a:solidFill>
+            <a:schemeClr val="bg1"/>
+          </a:solidFill>
+          <a:ln/>
+        </p:spPr>
+      </p:sp>
+      <p:sp>
+        <p:nvSpPr>
+          <p:cNvPr id="24" name="a6-n3"/>
+          <p:cNvSpPr txBox="1"/>
+          <p:nvPr/>
+        </p:nvSpPr>
+        <p:spPr>
+          <a:xfrm>
+            <a:off x="7178040" y="5166360"/>
+            <a:ext cx="3931920" cy="603504"/>
+          </a:xfrm>
+          <a:prstGeom prst="rect">
+            <a:avLst/>
+          </a:prstGeom>
+          <a:noFill/>
+          <a:ln/>
+        </p:spPr>
+        <p:txBody>
+          <a:bodyPr wrap="square" lIns="0" tIns="0" rIns="0" bIns="0" rtlCol="0" anchor="ctr"/>
+          <a:lstStyle/>
+          <a:p>
+            <a:pPr indent="0" marL="0">
+              <a:buNone/>
+            </a:pPr>
+            <a:r>
+              <a:rPr lang="en-US" sz="1500" b="1" dirty="0">
+                <a:solidFill>
+                  <a:schemeClr val="tx2"/>
+                </a:solidFill>
+              </a:rPr>
+              <a:t>Tanncam Investment Pte. Ltd.</a:t>
+            </a:r>
+            <a:endParaRPr lang="en-US" sz="1500" dirty="0"/>
+          </a:p>
+        </p:txBody>
+      </p:sp>
+      <p:sp>
+        <p:nvSpPr>
+          <p:cNvPr id="25" name="Slide Number Placeholder 0"/>
+          <p:cNvSpPr>
+            <a:spLocks noGrp="1"/>
+          </p:cNvSpPr>
+          <p:nvPr>
+            <p:ph type="sldNum" sz="quarter" idx="4294967295"/>
+          </p:nvPr>
+        </p:nvSpPr>
+        <p:spPr>
+          <a:xfrm>
+            <a:off x="548640" y="6355080"/>
+            <a:ext cx="548640" cy="320040"/>
+          </a:xfrm>
+          <a:prstGeom prst="rect">
+            <a:avLst/>
+          </a:prstGeom>
+          <a:extLst>
+            <a:ext uri="{C572A759-6A51-4108-AA02-DFA0A04FC94B}">
+              <ma14:wrappingTextBoxFlag xmlns:ma14="http://schemas.microsoft.com/office/mac/drawingml/2011/main" val="0"/>
+            </a:ext>
+          </a:extLst>
+        </p:spPr>
+        <p:txBody>
+          <a:bodyPr lIns="0" tIns="0" rIns="0" bIns="0"/>
+          <a:lstStyle>
+            <a:lvl1pPr>
+              <a:defRPr sz="1100">
+                <a:solidFill>
+                  <a:schemeClr val="accent5"/>
+                </a:solidFill>
+              </a:defRPr>
+            </a:lvl1pPr>
+          </a:lstStyle>
+          <a:p>
+            <a:pPr algn="l"/>
+            <a:fld id="{F7021451-1387-4CA6-816F-3879F97B5CBC}" type="slidenum">
+              <a:rPr b="0" lang="en-US"/>
+              <a:t>10</a:t>
+            </a:fld>
+            <a:endParaRPr lang="en-US"/>
+          </a:p>
+        </p:txBody>
+      </p:sp>
+    </p:spTree>
+  </p:cSld>
+  <p:clrMapOvr>
+    <a:masterClrMapping/>
+  </p:clrMapOvr>
+  <p:transition spd="med">
+    <p:push dir="l"/>
+  </p:transition>
+  <p:timing>
+    <p:tnLst>
+      <p:par>
+        <p:cTn id="1" dur="indefinite" restart="never" nodeType="tmRoot">
+          <p:childTnLst>
+            <p:seq concurrent="1" nextAc="seek">
+              <p:cTn id="2" dur="indefinite" nodeType="mainSeq">
+                <p:childTnLst>
+                  <p:par>
+                    <p:cTn id="3" fill="hold">
+                      <p:stCondLst>
+                        <p:cond delay="indefinite"/>
+                        <p:cond evt="onBegin" delay="0">
+                          <p:tn val="2"/>
+                        </p:cond>
+                      </p:stCondLst>
+                      <p:childTnLst>
+                        <p:par>
+                          <p:cTn id="7" fill="hold">
+                            <p:stCondLst>
+                              <p:cond delay="300"/>
+                            </p:stCondLst>
+                            <p:childTnLst>
+                              <p:par>
+                                <p:cTn id="4" presetID="10" presetClass="entr" presetSubtype="0" fill="hold" grpId="0" nodeType="afterEffect">
+                                  <p:stCondLst>
+                                    <p:cond delay="0"/>
+                                  </p:stCondLst>
+                                  <p:childTnLst>
+                                    <p:set>
+                                      <p:cBhvr>
+                                        <p:cTn id="5" dur="1" fill="hold">
+                                          <p:stCondLst>
+                                            <p:cond delay="0"/>
+                                          </p:stCondLst>
+                                        </p:cTn>
+                                        <p:tgtEl>
+                                          <p:spTgt spid="3"/>
+                                        </p:tgtEl>
+                                        <p:attrNameLst>
+                                          <p:attrName>style.visibility</p:attrName>
+                                        </p:attrNameLst>
+                                      </p:cBhvr>
+                                      <p:to>
+                                        <p:strVal val="visible"/>
+                                      </p:to>
+                                    </p:set>
+                                    <p:animEffect transition="in" filter="fade">
+                                      <p:cBhvr>
+                                        <p:cTn id="6" dur="500"/>
+                                        <p:tgtEl>
+                                          <p:spTgt spid="3"/>
+                                        </p:tgtEl>
+                                      </p:cBhvr>
+                                    </p:animEffect>
+                                  </p:childTnLst>
+                                </p:cTn>
+                              </p:par>
+                            </p:childTnLst>
+                          </p:cTn>
+                        </p:par>
+                        <p:par>
+                          <p:cTn id="17" fill="hold">
+                            <p:stCondLst>
+                              <p:cond delay="750"/>
+                            </p:stCondLst>
+                            <p:childTnLst>
+                              <p:par>
+                                <p:cTn id="8" presetID="10" presetClass="entr" presetSubtype="0" fill="hold" grpId="0" nodeType="afterEffect">
+                                  <p:stCondLst>
+                                    <p:cond delay="0"/>
+                                  </p:stCondLst>
+                                  <p:childTnLst>
+                                    <p:set>
+                                      <p:cBhvr>
+                                        <p:cTn id="9" dur="1" fill="hold">
+                                          <p:stCondLst>
+                                            <p:cond delay="0"/>
+                                          </p:stCondLst>
+                                        </p:cTn>
+                                        <p:tgtEl>
+                                          <p:spTgt spid="4"/>
+                                        </p:tgtEl>
+                                        <p:attrNameLst>
+                                          <p:attrName>style.visibility</p:attrName>
+                                        </p:attrNameLst>
+                                      </p:cBhvr>
+                                      <p:to>
+                                        <p:strVal val="visible"/>
+                                      </p:to>
+                                    </p:set>
+                                    <p:animEffect transition="in" filter="fade">
+                                      <p:cBhvr>
+                                        <p:cTn id="10" dur="500"/>
+                                        <p:tgtEl>
+                                          <p:spTgt spid="4"/>
+                                        </p:tgtEl>
+                                      </p:cBhvr>
+                                    </p:animEffect>
+                                  </p:childTnLst>
+                                </p:cTn>
+                              </p:par>
+                              <p:par>
+                                <p:cTn id="11" presetID="10" presetClass="entr" presetSubtype="0" fill="hold" grpId="0" nodeType="withEffect">
+                                  <p:stCondLst>
+                                    <p:cond delay="0"/>
+                                  </p:stCondLst>
+                                  <p:childTnLst>
+                                    <p:set>
+                                      <p:cBhvr>
+                                        <p:cTn id="12" dur="1" fill="hold">
+                                          <p:stCondLst>
+                                            <p:cond delay="0"/>
+                                          </p:stCondLst>
+                                        </p:cTn>
+                                        <p:tgtEl>
+                                          <p:spTgt spid="5"/>
+                                        </p:tgtEl>
+                                        <p:attrNameLst>
+                                          <p:attrName>style.visibility</p:attrName>
+                                        </p:attrNameLst>
+                                      </p:cBhvr>
+                                      <p:to>
+                                        <p:strVal val="visible"/>
+                                      </p:to>
+                                    </p:set>
+                                    <p:animEffect transition="in" filter="fade">
+                                      <p:cBhvr>
+                                        <p:cTn id="13" dur="500"/>
+                                        <p:tgtEl>
+                                          <p:spTgt spid="5"/>
+                                        </p:tgtEl>
+                                      </p:cBhvr>
+                                    </p:animEffect>
+                                  </p:childTnLst>
+                                </p:cTn>
+                              </p:par>
+                              <p:par>
+                                <p:cTn id="14" presetID="10" presetClass="entr" presetSubtype="0" fill="hold" grpId="0" nodeType="withEffect">
+                                  <p:stCondLst>
+                                    <p:cond delay="0"/>
+                                  </p:stCondLst>
+                                  <p:childTnLst>
+                                    <p:set>
+                                      <p:cBhvr>
+                                        <p:cTn id="15" dur="1" fill="hold">
+                                          <p:stCondLst>
+                                            <p:cond delay="0"/>
+                                          </p:stCondLst>
+                                        </p:cTn>
+                                        <p:tgtEl>
+                                          <p:spTgt spid="6"/>
+                                        </p:tgtEl>
+                                        <p:attrNameLst>
+                                          <p:attrName>style.visibility</p:attrName>
+                                        </p:attrNameLst>
+                                      </p:cBhvr>
+                                      <p:to>
+                                        <p:strVal val="visible"/>
+                                      </p:to>
+                                    </p:set>
+                                    <p:animEffect transition="in" filter="fade">
+                                      <p:cBhvr>
+                                        <p:cTn id="16" dur="500"/>
+                                        <p:tgtEl>
+                                          <p:spTgt spid="6"/>
+                                        </p:tgtEl>
+                                      </p:cBhvr>
+                                    </p:animEffect>
+                                  </p:childTnLst>
+                                </p:cTn>
+                              </p:par>
+                            </p:childTnLst>
+                          </p:cTn>
+                        </p:par>
+                        <p:par>
+                          <p:cTn id="27" fill="hold">
+                            <p:stCondLst>
+                              <p:cond delay="1200"/>
+                            </p:stCondLst>
+                            <p:childTnLst>
+                              <p:par>
+                                <p:cTn id="18" presetID="10" presetClass="entr" presetSubtype="0" fill="hold" grpId="0" nodeType="afterEffect">
+                                  <p:stCondLst>
+                                    <p:cond delay="0"/>
+                                  </p:stCondLst>
+                                  <p:childTnLst>
+                                    <p:set>
+                                      <p:cBhvr>
+                                        <p:cTn id="19" dur="1" fill="hold">
+                                          <p:stCondLst>
+                                            <p:cond delay="0"/>
+                                          </p:stCondLst>
+                                        </p:cTn>
+                                        <p:tgtEl>
+                                          <p:spTgt spid="7"/>
+                                        </p:tgtEl>
+                                        <p:attrNameLst>
+                                          <p:attrName>style.visibility</p:attrName>
+                                        </p:attrNameLst>
+                                      </p:cBhvr>
+                                      <p:to>
+                                        <p:strVal val="visible"/>
+                                      </p:to>
+                                    </p:set>
+                                    <p:animEffect transition="in" filter="fade">
+                                      <p:cBhvr>
+                                        <p:cTn id="20" dur="500"/>
+                                        <p:tgtEl>
+                                          <p:spTgt spid="7"/>
+                                        </p:tgtEl>
+                                      </p:cBhvr>
+                                    </p:animEffect>
+                                  </p:childTnLst>
+                                </p:cTn>
+                              </p:par>
+                              <p:par>
+                                <p:cTn id="21" presetID="10" presetClass="entr" presetSubtype="0" fill="hold" grpId="0" nodeType="withEffect">
+                                  <p:stCondLst>
+                                    <p:cond delay="0"/>
+                                  </p:stCondLst>
+                                  <p:childTnLst>
+                                    <p:set>
+                                      <p:cBhvr>
+                                        <p:cTn id="22" dur="1" fill="hold">
+                                          <p:stCondLst>
+                                            <p:cond delay="0"/>
+                                          </p:stCondLst>
+                                        </p:cTn>
+                                        <p:tgtEl>
+                                          <p:spTgt spid="8"/>
+                                        </p:tgtEl>
+                                        <p:attrNameLst>
+                                          <p:attrName>style.visibility</p:attrName>
+                                        </p:attrNameLst>
+                                      </p:cBhvr>
+                                      <p:to>
+                                        <p:strVal val="visible"/>
+                                      </p:to>
+                                    </p:set>
+                                    <p:animEffect transition="in" filter="fade">
+                                      <p:cBhvr>
+                                        <p:cTn id="23" dur="500"/>
+                                        <p:tgtEl>
+                                          <p:spTgt spid="8"/>
+                                        </p:tgtEl>
+                                      </p:cBhvr>
+                                    </p:animEffect>
+                                  </p:childTnLst>
+                                </p:cTn>
+                              </p:par>
+                              <p:par>
+                                <p:cTn id="24" presetID="10" presetClass="entr" presetSubtype="0" fill="hold" grpId="0" nodeType="withEffect">
+                                  <p:stCondLst>
+                                    <p:cond delay="0"/>
+                                  </p:stCondLst>
+                                  <p:childTnLst>
+                                    <p:set>
+                                      <p:cBhvr>
+                                        <p:cTn id="25" dur="1" fill="hold">
+                                          <p:stCondLst>
+                                            <p:cond delay="0"/>
+                                          </p:stCondLst>
+                                        </p:cTn>
+                                        <p:tgtEl>
+                                          <p:spTgt spid="9"/>
+                                        </p:tgtEl>
+                                        <p:attrNameLst>
+                                          <p:attrName>style.visibility</p:attrName>
+                                        </p:attrNameLst>
+                                      </p:cBhvr>
+                                      <p:to>
+                                        <p:strVal val="visible"/>
+                                      </p:to>
+                                    </p:set>
+                                    <p:animEffect transition="in" filter="fade">
+                                      <p:cBhvr>
+                                        <p:cTn id="26" dur="500"/>
+                                        <p:tgtEl>
+                                          <p:spTgt spid="9"/>
+                                        </p:tgtEl>
+                                      </p:cBhvr>
+                                    </p:animEffect>
+                                  </p:childTnLst>
+                                </p:cTn>
+                              </p:par>
+                            </p:childTnLst>
+                          </p:cTn>
+                        </p:par>
+                        <p:par>
+                          <p:cTn id="37" fill="hold">
+                            <p:stCondLst>
+                              <p:cond delay="1650"/>
+                            </p:stCondLst>
+                            <p:childTnLst>
+                              <p:par>
+                                <p:cTn id="28" presetID="10" presetClass="entr" presetSubtype="0" fill="hold" grpId="0" nodeType="afterEffect">
+                                  <p:stCondLst>
+                                    <p:cond delay="0"/>
+                                  </p:stCondLst>
+                                  <p:childTnLst>
+                                    <p:set>
+                                      <p:cBhvr>
+                                        <p:cTn id="29" dur="1" fill="hold">
+                                          <p:stCondLst>
+                                            <p:cond delay="0"/>
+                                          </p:stCondLst>
+                                        </p:cTn>
+                                        <p:tgtEl>
+                                          <p:spTgt spid="10"/>
+                                        </p:tgtEl>
+                                        <p:attrNameLst>
+                                          <p:attrName>style.visibility</p:attrName>
+                                        </p:attrNameLst>
+                                      </p:cBhvr>
+                                      <p:to>
+                                        <p:strVal val="visible"/>
+                                      </p:to>
+                                    </p:set>
+                                    <p:animEffect transition="in" filter="fade">
+                                      <p:cBhvr>
+                                        <p:cTn id="30" dur="500"/>
+                                        <p:tgtEl>
+                                          <p:spTgt spid="10"/>
+                                        </p:tgtEl>
+                                      </p:cBhvr>
+                                    </p:animEffect>
+                                  </p:childTnLst>
+                                </p:cTn>
+                              </p:par>
+                              <p:par>
+                                <p:cTn id="31" presetID="10" presetClass="entr" presetSubtype="0" fill="hold" grpId="0" nodeType="withEffect">
+                                  <p:stCondLst>
+                                    <p:cond delay="0"/>
+                                  </p:stCondLst>
+                                  <p:childTnLst>
+                                    <p:set>
+                                      <p:cBhvr>
+                                        <p:cTn id="32" dur="1" fill="hold">
+                                          <p:stCondLst>
+                                            <p:cond delay="0"/>
+                                          </p:stCondLst>
+                                        </p:cTn>
+                                        <p:tgtEl>
+                                          <p:spTgt spid="11"/>
+                                        </p:tgtEl>
+                                        <p:attrNameLst>
+                                          <p:attrName>style.visibility</p:attrName>
+                                        </p:attrNameLst>
+                                      </p:cBhvr>
+                                      <p:to>
+                                        <p:strVal val="visible"/>
+                                      </p:to>
+                                    </p:set>
+                                    <p:animEffect transition="in" filter="fade">
+                                      <p:cBhvr>
+                                        <p:cTn id="33" dur="500"/>
+                                        <p:tgtEl>
+                                          <p:spTgt spid="11"/>
+                                        </p:tgtEl>
+                                      </p:cBhvr>
+                                    </p:animEffect>
+                                  </p:childTnLst>
+                                </p:cTn>
+                              </p:par>
+                              <p:par>
+                                <p:cTn id="34" presetID="10" presetClass="entr" presetSubtype="0" fill="hold" grpId="0" nodeType="withEffect">
+                                  <p:stCondLst>
+                                    <p:cond delay="0"/>
+                                  </p:stCondLst>
+                                  <p:childTnLst>
+                                    <p:set>
+                                      <p:cBhvr>
+                                        <p:cTn id="35" dur="1" fill="hold">
+                                          <p:stCondLst>
+                                            <p:cond delay="0"/>
+                                          </p:stCondLst>
+                                        </p:cTn>
+                                        <p:tgtEl>
+                                          <p:spTgt spid="12"/>
+                                        </p:tgtEl>
+                                        <p:attrNameLst>
+                                          <p:attrName>style.visibility</p:attrName>
+                                        </p:attrNameLst>
+                                      </p:cBhvr>
+                                      <p:to>
+                                        <p:strVal val="visible"/>
+                                      </p:to>
+                                    </p:set>
+                                    <p:animEffect transition="in" filter="fade">
+                                      <p:cBhvr>
+                                        <p:cTn id="36" dur="500"/>
+                                        <p:tgtEl>
+                                          <p:spTgt spid="12"/>
+                                        </p:tgtEl>
+                                      </p:cBhvr>
+                                    </p:animEffect>
+                                  </p:childTnLst>
+                                </p:cTn>
+                              </p:par>
+                            </p:childTnLst>
+                          </p:cTn>
+                        </p:par>
+                        <p:par>
+                          <p:cTn id="47" fill="hold">
+                            <p:stCondLst>
+                              <p:cond delay="2100"/>
+                            </p:stCondLst>
+                            <p:childTnLst>
+                              <p:par>
+                                <p:cTn id="38" presetID="10" presetClass="entr" presetSubtype="0" fill="hold" grpId="0" nodeType="afterEffect">
+                                  <p:stCondLst>
+                                    <p:cond delay="0"/>
+                                  </p:stCondLst>
+                                  <p:childTnLst>
+                                    <p:set>
+                                      <p:cBhvr>
+                                        <p:cTn id="39" dur="1" fill="hold">
+                                          <p:stCondLst>
+                                            <p:cond delay="0"/>
+                                          </p:stCondLst>
+                                        </p:cTn>
+                                        <p:tgtEl>
+                                          <p:spTgt spid="13"/>
+                                        </p:tgtEl>
+                                        <p:attrNameLst>
+                                          <p:attrName>style.visibility</p:attrName>
+                                        </p:attrNameLst>
+                                      </p:cBhvr>
+                                      <p:to>
+                                        <p:strVal val="visible"/>
+                                      </p:to>
+                                    </p:set>
+                                    <p:animEffect transition="in" filter="fade">
+                                      <p:cBhvr>
+                                        <p:cTn id="40" dur="500"/>
+                                        <p:tgtEl>
+                                          <p:spTgt spid="13"/>
+                                        </p:tgtEl>
+                                      </p:cBhvr>
+                                    </p:animEffect>
+                                  </p:childTnLst>
+                                </p:cTn>
+                              </p:par>
+                              <p:par>
+                                <p:cTn id="41" presetID="10" presetClass="entr" presetSubtype="0" fill="hold" grpId="0" nodeType="withEffect">
+                                  <p:stCondLst>
+                                    <p:cond delay="0"/>
+                                  </p:stCondLst>
+                                  <p:childTnLst>
+                                    <p:set>
+                                      <p:cBhvr>
+                                        <p:cTn id="42" dur="1" fill="hold">
+                                          <p:stCondLst>
+                                            <p:cond delay="0"/>
+                                          </p:stCondLst>
+                                        </p:cTn>
+                                        <p:tgtEl>
+                                          <p:spTgt spid="14"/>
+                                        </p:tgtEl>
+                                        <p:attrNameLst>
+                                          <p:attrName>style.visibility</p:attrName>
+                                        </p:attrNameLst>
+                                      </p:cBhvr>
+                                      <p:to>
+                                        <p:strVal val="visible"/>
+                                      </p:to>
+                                    </p:set>
+                                    <p:animEffect transition="in" filter="fade">
+                                      <p:cBhvr>
+                                        <p:cTn id="43" dur="500"/>
+                                        <p:tgtEl>
+                                          <p:spTgt spid="14"/>
+                                        </p:tgtEl>
+                                      </p:cBhvr>
+                                    </p:animEffect>
+                                  </p:childTnLst>
+                                </p:cTn>
+                              </p:par>
+                              <p:par>
+                                <p:cTn id="44" presetID="10" presetClass="entr" presetSubtype="0" fill="hold" grpId="0" nodeType="withEffect">
+                                  <p:stCondLst>
+                                    <p:cond delay="0"/>
+                                  </p:stCondLst>
+                                  <p:childTnLst>
+                                    <p:set>
+                                      <p:cBhvr>
+                                        <p:cTn id="45" dur="1" fill="hold">
+                                          <p:stCondLst>
+                                            <p:cond delay="0"/>
+                                          </p:stCondLst>
+                                        </p:cTn>
+                                        <p:tgtEl>
+                                          <p:spTgt spid="15"/>
+                                        </p:tgtEl>
+                                        <p:attrNameLst>
+                                          <p:attrName>style.visibility</p:attrName>
+                                        </p:attrNameLst>
+                                      </p:cBhvr>
+                                      <p:to>
+                                        <p:strVal val="visible"/>
+                                      </p:to>
+                                    </p:set>
+                                    <p:animEffect transition="in" filter="fade">
+                                      <p:cBhvr>
+                                        <p:cTn id="46" dur="500"/>
+                                        <p:tgtEl>
+                                          <p:spTgt spid="15"/>
+                                        </p:tgtEl>
+                                      </p:cBhvr>
+                                    </p:animEffect>
+                                  </p:childTnLst>
+                                </p:cTn>
+                              </p:par>
+                            </p:childTnLst>
+                          </p:cTn>
+                        </p:par>
+                        <p:par>
+                          <p:cTn id="75" fill="hold">
+                            <p:stCondLst>
+                              <p:cond delay="2550"/>
+                            </p:stCondLst>
+                            <p:childTnLst>
+                              <p:par>
+                                <p:cTn id="48" presetID="10" presetClass="entr" presetSubtype="0" fill="hold" grpId="0" nodeType="afterEffect">
+                                  <p:stCondLst>
+                                    <p:cond delay="0"/>
+                                  </p:stCondLst>
+                                  <p:childTnLst>
+                                    <p:set>
+                                      <p:cBhvr>
+                                        <p:cTn id="49" dur="1" fill="hold">
+                                          <p:stCondLst>
+                                            <p:cond delay="0"/>
+                                          </p:stCondLst>
+                                        </p:cTn>
+                                        <p:tgtEl>
+                                          <p:spTgt spid="16"/>
+                                        </p:tgtEl>
+                                        <p:attrNameLst>
+                                          <p:attrName>style.visibility</p:attrName>
+                                        </p:attrNameLst>
+                                      </p:cBhvr>
+                                      <p:to>
+                                        <p:strVal val="visible"/>
+                                      </p:to>
+                                    </p:set>
+                                    <p:animEffect transition="in" filter="fade">
+                                      <p:cBhvr>
+                                        <p:cTn id="50" dur="500"/>
+                                        <p:tgtEl>
+                                          <p:spTgt spid="16"/>
+                                        </p:tgtEl>
+                                      </p:cBhvr>
+                                    </p:animEffect>
+                                  </p:childTnLst>
+                                </p:cTn>
+                              </p:par>
+                              <p:par>
+                                <p:cTn id="51" presetID="10" presetClass="entr" presetSubtype="0" fill="hold" grpId="0" nodeType="withEffect">
+                                  <p:stCondLst>
+                                    <p:cond delay="0"/>
+                                  </p:stCondLst>
+                                  <p:childTnLst>
+                                    <p:set>
+                                      <p:cBhvr>
+                                        <p:cTn id="52" dur="1" fill="hold">
+                                          <p:stCondLst>
+                                            <p:cond delay="0"/>
+                                          </p:stCondLst>
+                                        </p:cTn>
+                                        <p:tgtEl>
+                                          <p:spTgt spid="17"/>
+                                        </p:tgtEl>
+                                        <p:attrNameLst>
+                                          <p:attrName>style.visibility</p:attrName>
+                                        </p:attrNameLst>
+                                      </p:cBhvr>
+                                      <p:to>
+                                        <p:strVal val="visible"/>
+                                      </p:to>
+                                    </p:set>
+                                    <p:animEffect transition="in" filter="fade">
+                                      <p:cBhvr>
+                                        <p:cTn id="53" dur="500"/>
+                                        <p:tgtEl>
+                                          <p:spTgt spid="17"/>
+                                        </p:tgtEl>
+                                      </p:cBhvr>
+                                    </p:animEffect>
+                                  </p:childTnLst>
+                                </p:cTn>
+                              </p:par>
+                              <p:par>
+                                <p:cTn id="54" presetID="10" presetClass="entr" presetSubtype="0" fill="hold" grpId="0" nodeType="withEffect">
+                                  <p:stCondLst>
+                                    <p:cond delay="0"/>
+                                  </p:stCondLst>
+                                  <p:childTnLst>
+                                    <p:set>
+                                      <p:cBhvr>
+                                        <p:cTn id="55" dur="1" fill="hold">
+                                          <p:stCondLst>
+                                            <p:cond delay="0"/>
+                                          </p:stCondLst>
+                                        </p:cTn>
+                                        <p:tgtEl>
+                                          <p:spTgt spid="18"/>
+                                        </p:tgtEl>
+                                        <p:attrNameLst>
+                                          <p:attrName>style.visibility</p:attrName>
+                                        </p:attrNameLst>
+                                      </p:cBhvr>
+                                      <p:to>
+                                        <p:strVal val="visible"/>
+                                      </p:to>
+                                    </p:set>
+                                    <p:animEffect transition="in" filter="fade">
+                                      <p:cBhvr>
+                                        <p:cTn id="56" dur="500"/>
+                                        <p:tgtEl>
+                                          <p:spTgt spid="18"/>
+                                        </p:tgtEl>
+                                      </p:cBhvr>
+                                    </p:animEffect>
+                                  </p:childTnLst>
+                                </p:cTn>
+                              </p:par>
+                              <p:par>
+                                <p:cTn id="57" presetID="10" presetClass="entr" presetSubtype="0" fill="hold" grpId="0" nodeType="withEffect">
+                                  <p:stCondLst>
+                                    <p:cond delay="0"/>
+                                  </p:stCondLst>
+                                  <p:childTnLst>
+                                    <p:set>
+                                      <p:cBhvr>
+                                        <p:cTn id="58" dur="1" fill="hold">
+                                          <p:stCondLst>
+                                            <p:cond delay="0"/>
+                                          </p:stCondLst>
+                                        </p:cTn>
+                                        <p:tgtEl>
+                                          <p:spTgt spid="19"/>
+                                        </p:tgtEl>
+                                        <p:attrNameLst>
+                                          <p:attrName>style.visibility</p:attrName>
+                                        </p:attrNameLst>
+                                      </p:cBhvr>
+                                      <p:to>
+                                        <p:strVal val="visible"/>
+                                      </p:to>
+                                    </p:set>
+                                    <p:animEffect transition="in" filter="fade">
+                                      <p:cBhvr>
+                                        <p:cTn id="59" dur="500"/>
+                                        <p:tgtEl>
+                                          <p:spTgt spid="19"/>
+                                        </p:tgtEl>
+                                      </p:cBhvr>
+                                    </p:animEffect>
+                                  </p:childTnLst>
+                                </p:cTn>
+                              </p:par>
+                              <p:par>
+                                <p:cTn id="60" presetID="10" presetClass="entr" presetSubtype="0" fill="hold" grpId="0" nodeType="withEffect">
+                                  <p:stCondLst>
+                                    <p:cond delay="0"/>
+                                  </p:stCondLst>
+                                  <p:childTnLst>
+                                    <p:set>
+                                      <p:cBhvr>
+                                        <p:cTn id="61" dur="1" fill="hold">
+                                          <p:stCondLst>
+                                            <p:cond delay="0"/>
+                                          </p:stCondLst>
+                                        </p:cTn>
+                                        <p:tgtEl>
+                                          <p:spTgt spid="20"/>
+                                        </p:tgtEl>
+                                        <p:attrNameLst>
+                                          <p:attrName>style.visibility</p:attrName>
+                                        </p:attrNameLst>
+                                      </p:cBhvr>
+                                      <p:to>
+                                        <p:strVal val="visible"/>
+                                      </p:to>
+                                    </p:set>
+                                    <p:animEffect transition="in" filter="fade">
+                                      <p:cBhvr>
+                                        <p:cTn id="62" dur="500"/>
+                                        <p:tgtEl>
+                                          <p:spTgt spid="20"/>
+                                        </p:tgtEl>
+                                      </p:cBhvr>
+                                    </p:animEffect>
+                                  </p:childTnLst>
+                                </p:cTn>
+                              </p:par>
+                              <p:par>
+                                <p:cTn id="63" presetID="10" presetClass="entr" presetSubtype="0" fill="hold" grpId="0" nodeType="withEffect">
+                                  <p:stCondLst>
+                                    <p:cond delay="0"/>
+                                  </p:stCondLst>
+                                  <p:childTnLst>
+                                    <p:set>
+                                      <p:cBhvr>
+                                        <p:cTn id="64" dur="1" fill="hold">
+                                          <p:stCondLst>
+                                            <p:cond delay="0"/>
+                                          </p:stCondLst>
+                                        </p:cTn>
+                                        <p:tgtEl>
+                                          <p:spTgt spid="21"/>
+                                        </p:tgtEl>
+                                        <p:attrNameLst>
+                                          <p:attrName>style.visibility</p:attrName>
+                                        </p:attrNameLst>
+                                      </p:cBhvr>
+                                      <p:to>
+                                        <p:strVal val="visible"/>
+                                      </p:to>
+                                    </p:set>
+                                    <p:animEffect transition="in" filter="fade">
+                                      <p:cBhvr>
+                                        <p:cTn id="65" dur="500"/>
+                                        <p:tgtEl>
+                                          <p:spTgt spid="21"/>
+                                        </p:tgtEl>
+                                      </p:cBhvr>
+                                    </p:animEffect>
+                                  </p:childTnLst>
+                                </p:cTn>
+                              </p:par>
+                              <p:par>
+                                <p:cTn id="66" presetID="10" presetClass="entr" presetSubtype="0" fill="hold" grpId="0" nodeType="withEffect">
+                                  <p:stCondLst>
+                                    <p:cond delay="0"/>
+                                  </p:stCondLst>
+                                  <p:childTnLst>
+                                    <p:set>
+                                      <p:cBhvr>
+                                        <p:cTn id="67" dur="1" fill="hold">
+                                          <p:stCondLst>
+                                            <p:cond delay="0"/>
+                                          </p:stCondLst>
+                                        </p:cTn>
+                                        <p:tgtEl>
+                                          <p:spTgt spid="22"/>
+                                        </p:tgtEl>
+                                        <p:attrNameLst>
+                                          <p:attrName>style.visibility</p:attrName>
+                                        </p:attrNameLst>
+                                      </p:cBhvr>
+                                      <p:to>
+                                        <p:strVal val="visible"/>
+                                      </p:to>
+                                    </p:set>
+                                    <p:animEffect transition="in" filter="fade">
+                                      <p:cBhvr>
+                                        <p:cTn id="68" dur="500"/>
+                                        <p:tgtEl>
+                                          <p:spTgt spid="22"/>
+                                        </p:tgtEl>
+                                      </p:cBhvr>
+                                    </p:animEffect>
+                                  </p:childTnLst>
+                                </p:cTn>
+                              </p:par>
+                              <p:par>
+                                <p:cTn id="69" presetID="10" presetClass="entr" presetSubtype="0" fill="hold" grpId="0" nodeType="withEffect">
+                                  <p:stCondLst>
+                                    <p:cond delay="0"/>
+                                  </p:stCondLst>
+                                  <p:childTnLst>
+                                    <p:set>
+                                      <p:cBhvr>
+                                        <p:cTn id="70" dur="1" fill="hold">
+                                          <p:stCondLst>
+                                            <p:cond delay="0"/>
+                                          </p:stCondLst>
+                                        </p:cTn>
+                                        <p:tgtEl>
+                                          <p:spTgt spid="23"/>
+                                        </p:tgtEl>
+                                        <p:attrNameLst>
+                                          <p:attrName>style.visibility</p:attrName>
+                                        </p:attrNameLst>
+                                      </p:cBhvr>
+                                      <p:to>
+                                        <p:strVal val="visible"/>
+                                      </p:to>
+                                    </p:set>
+                                    <p:animEffect transition="in" filter="fade">
+                                      <p:cBhvr>
+                                        <p:cTn id="71" dur="500"/>
+                                        <p:tgtEl>
+                                          <p:spTgt spid="23"/>
+                                        </p:tgtEl>
+                                      </p:cBhvr>
+                                    </p:animEffect>
+                                  </p:childTnLst>
+                                </p:cTn>
+                              </p:par>
+                              <p:par>
+                                <p:cTn id="72" presetID="10" presetClass="entr" presetSubtype="0" fill="hold" grpId="0" nodeType="withEffect">
+                                  <p:stCondLst>
+                                    <p:cond delay="0"/>
+                                  </p:stCondLst>
+                                  <p:childTnLst>
+                                    <p:set>
+                                      <p:cBhvr>
+                                        <p:cTn id="73" dur="1" fill="hold">
+                                          <p:stCondLst>
+                                            <p:cond delay="0"/>
+                                          </p:stCondLst>
+                                        </p:cTn>
+                                        <p:tgtEl>
+                                          <p:spTgt spid="24"/>
+                                        </p:tgtEl>
+                                        <p:attrNameLst>
+                                          <p:attrName>style.visibility</p:attrName>
+                                        </p:attrNameLst>
+                                      </p:cBhvr>
+                                      <p:to>
+                                        <p:strVal val="visible"/>
+                                      </p:to>
+                                    </p:set>
+                                    <p:animEffect transition="in" filter="fade">
+                                      <p:cBhvr>
+                                        <p:cTn id="74" dur="500"/>
+                                        <p:tgtEl>
+                                          <p:spTgt spid="24"/>
+                                        </p:tgtEl>
+                                      </p:cBhvr>
+                                    </p:animEffect>
+                                  </p:childTnLst>
+                                </p:cTn>
+                              </p:par>
+                            </p:childTnLst>
+                          </p:cTn>
+                        </p:par>
+                      </p:childTnLst>
+                    </p:cTn>
+                  </p:par>
+                </p:childTnLst>
+              </p:cTn>
+              <p:prevCondLst>
+                <p:cond evt="onPrev" delay="0">
+                  <p:tgtEl>
+                    <p:sldTgt/>
+                  </p:tgtEl>
+                </p:cond>
+              </p:prevCondLst>
+              <p:nextCondLst>
+                <p:cond evt="onNext" delay="0">
+                  <p:tgtEl>
+                    <p:sldTgt/>
+                  </p:tgtEl>
+                </p:cond>
+              </p:nextCondLst>
+            </p:seq>
+          </p:childTnLst>
+        </p:cTn>
+      </p:par>
+    </p:tnLst>
+    <p:bldLst>
+      <p:bldP spid="3" grpId="0" animBg="1"/>
+      <p:bldP spid="4" grpId="0" animBg="1"/>
+      <p:bldP spid="6" grpId="0" animBg="1"/>
+      <p:bldP spid="7" grpId="0" animBg="1"/>
+      <p:bldP spid="9" grpId="0" animBg="1"/>
+      <p:bldP spid="10" grpId="0" animBg="1"/>
+      <p:bldP spid="12" grpId="0" animBg="1"/>
+      <p:bldP spid="13" grpId="0" animBg="1"/>
+      <p:bldP spid="14" grpId="0" animBg="1"/>
+      <p:bldP spid="15" grpId="0" animBg="1"/>
+      <p:bldP spid="16" grpId="0" animBg="1"/>
+      <p:bldP spid="17" grpId="0" animBg="1"/>
+      <p:bldP spid="18" grpId="0" animBg="1"/>
+      <p:bldP spid="19" grpId="0" animBg="1"/>
+      <p:bldP spid="20" grpId="0" animBg="1"/>
+      <p:bldP spid="21" grpId="0" animBg="1"/>
+      <p:bldP spid="22" grpId="0" animBg="1"/>
+      <p:bldP spid="23" grpId="0" animBg="1"/>
+      <p:bldP spid="24" grpId="0" animBg="1"/>
+    </p:bldLst>
+  </p:timing>
+</p:sld>
+</file>
+
+<file path=ppt/slides/slide11.xml><?xml version="1.0" encoding="utf-8"?>
+<p:sld xmlns:a="http://schemas.openxmlformats.org/drawingml/2006/main" xmlns:r="http://schemas.openxmlformats.org/officeDocument/2006/relationships" xmlns:p="http://schemas.openxmlformats.org/presentationml/2006/main">
+  <p:cSld name="Slide 11">
+    <p:spTree>
+      <p:nvGrpSpPr>
+        <p:cNvPr id="1" name=""/>
+        <p:cNvGrpSpPr/>
+        <p:nvPr/>
+      </p:nvGrpSpPr>
+      <p:grpSpPr>
+        <a:xfrm>
+          <a:off x="0" y="0"/>
+          <a:ext cx="0" cy="0"/>
+          <a:chOff x="0" y="0"/>
+          <a:chExt cx="0" cy="0"/>
+        </a:xfrm>
+      </p:grpSpPr>
+      <p:sp>
+        <p:nvSpPr>
+          <p:cNvPr id="2" name="Text 0"/>
+          <p:cNvSpPr/>
+          <p:nvPr>
+            <p:ph idx="101" type="title" hasCustomPrompt="1"/>
+          </p:nvPr>
+        </p:nvSpPr>
+        <p:spPr>
+          <a:xfrm>
+            <a:off x="548640" y="365760"/>
+            <a:ext cx="9509760" cy="777240"/>
+          </a:xfrm>
+          <a:prstGeom prst="rect">
+            <a:avLst/>
+          </a:prstGeom>
+          <a:noFill/>
+          <a:ln/>
+        </p:spPr>
+        <p:txBody>
+          <a:bodyPr wrap="square" lIns="0" tIns="0" rIns="0" bIns="0" rtlCol="0" anchor="ctr"/>
+          <a:lstStyle/>
+          <a:p>
+            <a:pPr algn="l" indent="0" marL="0">
+              <a:buNone/>
+            </a:pPr>
+            <a:r>
+              <a:rPr lang="en-US" sz="3600" b="1" dirty="0">
+                <a:solidFill>
+                  <a:schemeClr val="tx2"/>
+                </a:solidFill>
+              </a:rPr>
               <a:t>We Prepare. You File.</a:t>
             </a:r>
             <a:endParaRPr lang="en-US" sz="3600" dirty="0"/>
@@ -3544,7 +5316,7 @@
             <a:pPr algn="l"/>
             <a:fld id="{F7021451-1387-4CA6-816F-3879F97B5CBC}" type="slidenum">
               <a:rPr b="0" lang="en-US"/>
-              <a:t>10</a:t>
+              <a:t>11</a:t>
             </a:fld>
             <a:endParaRPr lang="en-US"/>
           </a:p>
@@ -4378,9 +6150,9 @@
 </p:sld>
 </file>
 
-<file path=ppt/slides/slide11.xml><?xml version="1.0" encoding="utf-8"?>
+<file path=ppt/slides/slide12.xml><?xml version="1.0" encoding="utf-8"?>
 <p:sld xmlns:a="http://schemas.openxmlformats.org/drawingml/2006/main" xmlns:r="http://schemas.openxmlformats.org/officeDocument/2006/relationships" xmlns:p="http://schemas.openxmlformats.org/presentationml/2006/main">
-  <p:cSld name="Slide 11">
+  <p:cSld name="Slide 12">
     <p:spTree>
       <p:nvGrpSpPr>
         <p:cNvPr id="1" name=""/>
@@ -5437,7 +7209,7 @@
             <a:pPr algn="l"/>
             <a:fld id="{F7021451-1387-4CA6-816F-3879F97B5CBC}" type="slidenum">
               <a:rPr b="0" lang="en-US"/>
-              <a:t>11</a:t>
+              <a:t>12</a:t>
             </a:fld>
             <a:endParaRPr lang="en-US"/>
           </a:p>
@@ -6734,9 +8506,9 @@
 </p:sld>
 </file>
 
-<file path=ppt/slides/slide12.xml><?xml version="1.0" encoding="utf-8"?>
+<file path=ppt/slides/slide13.xml><?xml version="1.0" encoding="utf-8"?>
 <p:sld xmlns:a="http://schemas.openxmlformats.org/drawingml/2006/main" xmlns:r="http://schemas.openxmlformats.org/officeDocument/2006/relationships" xmlns:p="http://schemas.openxmlformats.org/presentationml/2006/main">
-  <p:cSld name="Slide 12">
+  <p:cSld name="Slide 13">
     <p:spTree>
       <p:nvGrpSpPr>
         <p:cNvPr id="1" name=""/>
@@ -7392,7 +9164,7 @@
             <a:pPr algn="l"/>
             <a:fld id="{F7021451-1387-4CA6-816F-3879F97B5CBC}" type="slidenum">
               <a:rPr b="0" lang="en-US"/>
-              <a:t>12</a:t>
+              <a:t>13</a:t>
             </a:fld>
             <a:endParaRPr lang="en-US"/>
           </a:p>
@@ -8122,9 +9894,9 @@
 </p:sld>
 </file>
 
-<file path=ppt/slides/slide13.xml><?xml version="1.0" encoding="utf-8"?>
+<file path=ppt/slides/slide14.xml><?xml version="1.0" encoding="utf-8"?>
 <p:sld xmlns:a="http://schemas.openxmlformats.org/drawingml/2006/main" xmlns:r="http://schemas.openxmlformats.org/officeDocument/2006/relationships" xmlns:p="http://schemas.openxmlformats.org/presentationml/2006/main">
-  <p:cSld name="Slide 13">
+  <p:cSld name="Slide 14">
     <p:spTree>
       <p:nvGrpSpPr>
         <p:cNvPr id="1" name=""/>
@@ -8984,7 +10756,7 @@
             <a:pPr algn="l"/>
             <a:fld id="{F7021451-1387-4CA6-816F-3879F97B5CBC}" type="slidenum">
               <a:rPr b="0" lang="en-US"/>
-              <a:t>13</a:t>
+              <a:t>14</a:t>
             </a:fld>
             <a:endParaRPr lang="en-US"/>
           </a:p>
@@ -9976,9 +11748,9 @@
 </p:sld>
 </file>
 
-<file path=ppt/slides/slide14.xml><?xml version="1.0" encoding="utf-8"?>
+<file path=ppt/slides/slide15.xml><?xml version="1.0" encoding="utf-8"?>
 <p:sld xmlns:a="http://schemas.openxmlformats.org/drawingml/2006/main" xmlns:r="http://schemas.openxmlformats.org/officeDocument/2006/relationships" xmlns:p="http://schemas.openxmlformats.org/presentationml/2006/main">
-  <p:cSld name="Slide 14">
+  <p:cSld name="Slide 15">
     <p:spTree>
       <p:nvGrpSpPr>
         <p:cNvPr id="1" name=""/>
@@ -23637,7 +25409,7 @@
                   <a:schemeClr val="tx2"/>
                 </a:solidFill>
               </a:rPr>
-              <a:t>United States &amp; Singapore</a:t>
+              <a:t>United States</a:t>
             </a:r>
             <a:endParaRPr lang="en-US" sz="3600" dirty="0"/>
           </a:p>
@@ -23652,7 +25424,7 @@
         <p:spPr>
           <a:xfrm>
             <a:off x="548640" y="1143000"/>
-            <a:ext cx="10972800" cy="411480"/>
+            <a:ext cx="5852160" cy="411480"/>
           </a:xfrm>
           <a:prstGeom prst="rect">
             <a:avLst/>
@@ -23673,7 +25445,7 @@
                   <a:schemeClr val="accent5"/>
                 </a:solidFill>
               </a:rPr>
-              <a:t>Dedicated support built around the needs of small and mid-sized businesses.</a:t>
+              <a:t>Tax and advisory support for small and mid-sized businesses</a:t>
             </a:r>
             <a:endParaRPr lang="en-US" sz="1800" dirty="0"/>
           </a:p>
@@ -23681,47 +25453,13 @@
       </p:sp>
       <p:sp>
         <p:nvSpPr>
-          <p:cNvPr id="4" name="a2-c"/>
+          <p:cNvPr id="4" name="a2-d"/>
           <p:cNvSpPr/>
           <p:nvPr/>
         </p:nvSpPr>
         <p:spPr>
           <a:xfrm>
-            <a:off x="548640" y="1783080"/>
-            <a:ext cx="5394960" cy="3063240"/>
-          </a:xfrm>
-          <a:prstGeom prst="roundRect">
-            <a:avLst>
-              <a:gd name="adj" fmla="val 3582"/>
-            </a:avLst>
-          </a:prstGeom>
-          <a:solidFill>
-            <a:schemeClr val="bg1"/>
-          </a:solidFill>
-          <a:ln w="12700">
-            <a:solidFill>
-              <a:schemeClr val="accent4"/>
-            </a:solidFill>
-            <a:prstDash val="solid"/>
-          </a:ln>
-          <a:effectLst>
-            <a:outerShdw sx="100000" sy="100000" kx="0" ky="0" algn="bl" rotWithShape="0" blurRad="101600" dist="25400" dir="5400000">
-              <a:srgbClr val="1F2A6B">
-                <a:alpha val="12000"/>
-              </a:srgbClr>
-            </a:outerShdw>
-          </a:effectLst>
-        </p:spPr>
-      </p:sp>
-      <p:sp>
-        <p:nvSpPr>
-          <p:cNvPr id="5" name="a2-d"/>
-          <p:cNvSpPr/>
-          <p:nvPr/>
-        </p:nvSpPr>
-        <p:spPr>
-          <a:xfrm>
-            <a:off x="868680" y="2103120"/>
+            <a:off x="548640" y="1874520"/>
             <a:ext cx="868680" cy="868680"/>
           </a:xfrm>
           <a:prstGeom prst="ellipse">
@@ -23735,7 +25473,7 @@
       </p:sp>
       <p:pic>
         <p:nvPicPr>
-          <p:cNvPr id="6" name="a2-d-i" descr="preencoded.png">    </p:cNvPr>
+          <p:cNvPr id="5" name="a2-d-i" descr="preencoded.png">    </p:cNvPr>
           <p:cNvPicPr>
             <a:picLocks noChangeAspect="1"/>
           </p:cNvPicPr>
@@ -23749,7 +25487,7 @@
         </p:blipFill>
         <p:spPr>
           <a:xfrm>
-            <a:off x="1085850" y="2320290"/>
+            <a:off x="765810" y="2091690"/>
             <a:ext cx="434340" cy="434340"/>
           </a:xfrm>
           <a:prstGeom prst="rect">
@@ -23759,14 +25497,14 @@
       </p:pic>
       <p:sp>
         <p:nvSpPr>
-          <p:cNvPr id="7" name="a2-h"/>
+          <p:cNvPr id="6" name="a2-t"/>
           <p:cNvSpPr txBox="1"/>
           <p:nvPr/>
         </p:nvSpPr>
         <p:spPr>
           <a:xfrm>
-            <a:off x="1965960" y="2103120"/>
-            <a:ext cx="3749040" cy="502920"/>
+            <a:off x="1645920" y="1828800"/>
+            <a:ext cx="4663440" cy="960120"/>
           </a:xfrm>
           <a:prstGeom prst="rect">
             <a:avLst/>
@@ -23782,27 +25520,251 @@
               <a:buNone/>
             </a:pPr>
             <a:r>
-              <a:rPr lang="en-US" sz="2400" b="1" dirty="0">
+              <a:rPr lang="en-US" sz="2000" b="1" dirty="0">
                 <a:solidFill>
                   <a:schemeClr val="tx2"/>
                 </a:solidFill>
               </a:rPr>
-              <a:t>United States</a:t>
+              <a:t>Tax Return Preparation &amp; Filing</a:t>
             </a:r>
-            <a:endParaRPr lang="en-US" sz="2400" dirty="0"/>
+            <a:endParaRPr lang="en-US" sz="2000" dirty="0"/>
+          </a:p>
+          <a:p>
+            <a:pPr indent="0" marL="0">
+              <a:buNone/>
+            </a:pPr>
+            <a:r>
+              <a:rPr lang="en-US" sz="1500" dirty="0">
+                <a:solidFill>
+                  <a:schemeClr val="accent5"/>
+                </a:solidFill>
+              </a:rPr>
+              <a:t>Prepared accurately and filed on schedule</a:t>
+            </a:r>
+            <a:endParaRPr lang="en-US" sz="2000" dirty="0"/>
           </a:p>
         </p:txBody>
       </p:sp>
       <p:sp>
         <p:nvSpPr>
-          <p:cNvPr id="8" name="a2-s"/>
+          <p:cNvPr id="7" name="a3-d"/>
+          <p:cNvSpPr/>
+          <p:nvPr/>
+        </p:nvSpPr>
+        <p:spPr>
+          <a:xfrm>
+            <a:off x="548640" y="3200400"/>
+            <a:ext cx="868680" cy="868680"/>
+          </a:xfrm>
+          <a:prstGeom prst="ellipse">
+            <a:avLst/>
+          </a:prstGeom>
+          <a:solidFill>
+            <a:schemeClr val="tx2"/>
+          </a:solidFill>
+          <a:ln/>
+        </p:spPr>
+      </p:sp>
+      <p:pic>
+        <p:nvPicPr>
+          <p:cNvPr id="8" name="a3-d-i" descr="preencoded.png">    </p:cNvPr>
+          <p:cNvPicPr>
+            <a:picLocks noChangeAspect="1"/>
+          </p:cNvPicPr>
+          <p:nvPr/>
+        </p:nvPicPr>
+        <p:blipFill>
+          <a:blip r:embed="rId2"/>
+          <a:stretch>
+            <a:fillRect/>
+          </a:stretch>
+        </p:blipFill>
+        <p:spPr>
+          <a:xfrm>
+            <a:off x="765810" y="3417570"/>
+            <a:ext cx="434340" cy="434340"/>
+          </a:xfrm>
+          <a:prstGeom prst="rect">
+            <a:avLst/>
+          </a:prstGeom>
+        </p:spPr>
+      </p:pic>
+      <p:sp>
+        <p:nvSpPr>
+          <p:cNvPr id="9" name="a3-t"/>
           <p:cNvSpPr txBox="1"/>
           <p:nvPr/>
         </p:nvSpPr>
         <p:spPr>
           <a:xfrm>
-            <a:off x="1965960" y="2606040"/>
-            <a:ext cx="3749040" cy="320040"/>
+            <a:off x="1645920" y="3154680"/>
+            <a:ext cx="4663440" cy="960120"/>
+          </a:xfrm>
+          <a:prstGeom prst="rect">
+            <a:avLst/>
+          </a:prstGeom>
+          <a:noFill/>
+          <a:ln/>
+        </p:spPr>
+        <p:txBody>
+          <a:bodyPr wrap="square" lIns="0" tIns="0" rIns="0" bIns="0" rtlCol="0" anchor="ctr"/>
+          <a:lstStyle/>
+          <a:p>
+            <a:pPr indent="0" marL="0">
+              <a:buNone/>
+            </a:pPr>
+            <a:r>
+              <a:rPr lang="en-US" sz="2000" b="1" dirty="0">
+                <a:solidFill>
+                  <a:schemeClr val="tx2"/>
+                </a:solidFill>
+              </a:rPr>
+              <a:t>Tax &amp; Business Consulting</a:t>
+            </a:r>
+            <a:endParaRPr lang="en-US" sz="2000" dirty="0"/>
+          </a:p>
+          <a:p>
+            <a:pPr indent="0" marL="0">
+              <a:buNone/>
+            </a:pPr>
+            <a:r>
+              <a:rPr lang="en-US" sz="1500" dirty="0">
+                <a:solidFill>
+                  <a:schemeClr val="accent5"/>
+                </a:solidFill>
+              </a:rPr>
+              <a:t>Practical guidance for everyday decisions</a:t>
+            </a:r>
+            <a:endParaRPr lang="en-US" sz="2000" dirty="0"/>
+          </a:p>
+        </p:txBody>
+      </p:sp>
+      <p:sp>
+        <p:nvSpPr>
+          <p:cNvPr id="10" name="a4-d"/>
+          <p:cNvSpPr/>
+          <p:nvPr/>
+        </p:nvSpPr>
+        <p:spPr>
+          <a:xfrm>
+            <a:off x="548640" y="4526280"/>
+            <a:ext cx="868680" cy="868680"/>
+          </a:xfrm>
+          <a:prstGeom prst="ellipse">
+            <a:avLst/>
+          </a:prstGeom>
+          <a:solidFill>
+            <a:schemeClr val="accent1"/>
+          </a:solidFill>
+          <a:ln/>
+        </p:spPr>
+      </p:sp>
+      <p:pic>
+        <p:nvPicPr>
+          <p:cNvPr id="11" name="a4-d-i" descr="preencoded.png">    </p:cNvPr>
+          <p:cNvPicPr>
+            <a:picLocks noChangeAspect="1"/>
+          </p:cNvPicPr>
+          <p:nvPr/>
+        </p:nvPicPr>
+        <p:blipFill>
+          <a:blip r:embed="rId3"/>
+          <a:stretch>
+            <a:fillRect/>
+          </a:stretch>
+        </p:blipFill>
+        <p:spPr>
+          <a:xfrm>
+            <a:off x="765810" y="4743450"/>
+            <a:ext cx="434340" cy="434340"/>
+          </a:xfrm>
+          <a:prstGeom prst="rect">
+            <a:avLst/>
+          </a:prstGeom>
+        </p:spPr>
+      </p:pic>
+      <p:sp>
+        <p:nvSpPr>
+          <p:cNvPr id="12" name="a4-t"/>
+          <p:cNvSpPr txBox="1"/>
+          <p:nvPr/>
+        </p:nvSpPr>
+        <p:spPr>
+          <a:xfrm>
+            <a:off x="1645920" y="4480560"/>
+            <a:ext cx="4663440" cy="960120"/>
+          </a:xfrm>
+          <a:prstGeom prst="rect">
+            <a:avLst/>
+          </a:prstGeom>
+          <a:noFill/>
+          <a:ln/>
+        </p:spPr>
+        <p:txBody>
+          <a:bodyPr wrap="square" lIns="0" tIns="0" rIns="0" bIns="0" rtlCol="0" anchor="ctr"/>
+          <a:lstStyle/>
+          <a:p>
+            <a:pPr indent="0" marL="0">
+              <a:buNone/>
+            </a:pPr>
+            <a:r>
+              <a:rPr lang="en-US" sz="2000" b="1" dirty="0">
+                <a:solidFill>
+                  <a:schemeClr val="tx2"/>
+                </a:solidFill>
+              </a:rPr>
+              <a:t>Support That Scales</a:t>
+            </a:r>
+            <a:endParaRPr lang="en-US" sz="2000" dirty="0"/>
+          </a:p>
+          <a:p>
+            <a:pPr indent="0" marL="0">
+              <a:buNone/>
+            </a:pPr>
+            <a:r>
+              <a:rPr lang="en-US" sz="1500" dirty="0">
+                <a:solidFill>
+                  <a:schemeClr val="accent5"/>
+                </a:solidFill>
+              </a:rPr>
+              <a:t>Our help grows as the business grows</a:t>
+            </a:r>
+            <a:endParaRPr lang="en-US" sz="2000" dirty="0"/>
+          </a:p>
+        </p:txBody>
+      </p:sp>
+      <p:sp>
+        <p:nvSpPr>
+          <p:cNvPr id="13" name="a5-p"/>
+          <p:cNvSpPr/>
+          <p:nvPr/>
+        </p:nvSpPr>
+        <p:spPr>
+          <a:xfrm>
+            <a:off x="6583680" y="1417320"/>
+            <a:ext cx="5029200" cy="3895344"/>
+          </a:xfrm>
+          <a:prstGeom prst="roundRect">
+            <a:avLst>
+              <a:gd name="adj" fmla="val 2817"/>
+            </a:avLst>
+          </a:prstGeom>
+          <a:solidFill>
+            <a:schemeClr val="tx2"/>
+          </a:solidFill>
+          <a:ln/>
+        </p:spPr>
+      </p:sp>
+      <p:sp>
+        <p:nvSpPr>
+          <p:cNvPr id="14" name="a5-h"/>
+          <p:cNvSpPr txBox="1"/>
+          <p:nvPr/>
+        </p:nvSpPr>
+        <p:spPr>
+          <a:xfrm>
+            <a:off x="6949440" y="1691640"/>
+            <a:ext cx="4389120" cy="320040"/>
           </a:xfrm>
           <a:prstGeom prst="rect">
             <a:avLst/>
@@ -23820,49 +25782,25 @@
             <a:r>
               <a:rPr lang="en-US" sz="1300" b="1" spc="200" kern="0" dirty="0">
                 <a:solidFill>
-                  <a:schemeClr val="accent1"/>
+                  <a:schemeClr val="accent3"/>
                 </a:solidFill>
               </a:rPr>
-              <a:t>TAX &amp; ADVISORY FOR SMEs</a:t>
+              <a:t>WHO WE SERVE</a:t>
             </a:r>
             <a:endParaRPr lang="en-US" sz="1300" dirty="0"/>
           </a:p>
         </p:txBody>
       </p:sp>
-      <p:pic>
-        <p:nvPicPr>
-          <p:cNvPr id="9" name="a2-k0" descr="preencoded.png">    </p:cNvPr>
-          <p:cNvPicPr>
-            <a:picLocks noChangeAspect="1"/>
-          </p:cNvPicPr>
-          <p:nvPr/>
-        </p:nvPicPr>
-        <p:blipFill>
-          <a:blip r:embed="rId2"/>
-          <a:stretch>
-            <a:fillRect/>
-          </a:stretch>
-        </p:blipFill>
-        <p:spPr>
-          <a:xfrm>
-            <a:off x="914400" y="3319272"/>
-            <a:ext cx="274320" cy="274320"/>
-          </a:xfrm>
-          <a:prstGeom prst="rect">
-            <a:avLst/>
-          </a:prstGeom>
-        </p:spPr>
-      </p:pic>
-      <p:sp>
-        <p:nvSpPr>
-          <p:cNvPr id="10" name="a2-b0"/>
+      <p:sp>
+        <p:nvSpPr>
+          <p:cNvPr id="15" name="a5-t"/>
           <p:cNvSpPr txBox="1"/>
           <p:nvPr/>
         </p:nvSpPr>
         <p:spPr>
           <a:xfrm>
-            <a:off x="1371600" y="3246120"/>
-            <a:ext cx="4297680" cy="411480"/>
+            <a:off x="6949440" y="2011680"/>
+            <a:ext cx="4389120" cy="365760"/>
           </a:xfrm>
           <a:prstGeom prst="rect">
             <a:avLst/>
@@ -23878,261 +25816,27 @@
               <a:buNone/>
             </a:pPr>
             <a:r>
-              <a:rPr lang="en-US" sz="1600" dirty="0">
+              <a:rPr lang="en-US" sz="1700" b="1" dirty="0">
                 <a:solidFill>
-                  <a:schemeClr val="tx1"/>
+                  <a:schemeClr val="bg1"/>
                 </a:solidFill>
               </a:rPr>
-              <a:t>Tax return preparation and filing</a:t>
+              <a:t>Small &amp; mid-sized businesses (SMEs)</a:t>
             </a:r>
-            <a:endParaRPr lang="en-US" sz="1600" dirty="0"/>
+            <a:endParaRPr lang="en-US" sz="1700" dirty="0"/>
           </a:p>
         </p:txBody>
       </p:sp>
-      <p:pic>
-        <p:nvPicPr>
-          <p:cNvPr id="11" name="a2-k1" descr="preencoded.png">    </p:cNvPr>
-          <p:cNvPicPr>
-            <a:picLocks noChangeAspect="1"/>
-          </p:cNvPicPr>
-          <p:nvPr/>
-        </p:nvPicPr>
-        <p:blipFill>
-          <a:blip r:embed="rId3"/>
-          <a:stretch>
-            <a:fillRect/>
-          </a:stretch>
-        </p:blipFill>
-        <p:spPr>
-          <a:xfrm>
-            <a:off x="914400" y="3822192"/>
-            <a:ext cx="274320" cy="274320"/>
-          </a:xfrm>
-          <a:prstGeom prst="rect">
-            <a:avLst/>
-          </a:prstGeom>
-        </p:spPr>
-      </p:pic>
-      <p:sp>
-        <p:nvSpPr>
-          <p:cNvPr id="12" name="a2-b1"/>
+      <p:sp>
+        <p:nvSpPr>
+          <p:cNvPr id="16" name="a6-h"/>
           <p:cNvSpPr txBox="1"/>
           <p:nvPr/>
         </p:nvSpPr>
         <p:spPr>
           <a:xfrm>
-            <a:off x="1371600" y="3749040"/>
-            <a:ext cx="4297680" cy="411480"/>
-          </a:xfrm>
-          <a:prstGeom prst="rect">
-            <a:avLst/>
-          </a:prstGeom>
-          <a:noFill/>
-          <a:ln/>
-        </p:spPr>
-        <p:txBody>
-          <a:bodyPr wrap="square" lIns="0" tIns="0" rIns="0" bIns="0" rtlCol="0" anchor="ctr"/>
-          <a:lstStyle/>
-          <a:p>
-            <a:pPr indent="0" marL="0">
-              <a:buNone/>
-            </a:pPr>
-            <a:r>
-              <a:rPr lang="en-US" sz="1600" dirty="0">
-                <a:solidFill>
-                  <a:schemeClr val="tx1"/>
-                </a:solidFill>
-              </a:rPr>
-              <a:t>Tax and business consulting</a:t>
-            </a:r>
-            <a:endParaRPr lang="en-US" sz="1600" dirty="0"/>
-          </a:p>
-        </p:txBody>
-      </p:sp>
-      <p:pic>
-        <p:nvPicPr>
-          <p:cNvPr id="13" name="a2-k2" descr="preencoded.png">    </p:cNvPr>
-          <p:cNvPicPr>
-            <a:picLocks noChangeAspect="1"/>
-          </p:cNvPicPr>
-          <p:nvPr/>
-        </p:nvPicPr>
-        <p:blipFill>
-          <a:blip r:embed="rId4"/>
-          <a:stretch>
-            <a:fillRect/>
-          </a:stretch>
-        </p:blipFill>
-        <p:spPr>
-          <a:xfrm>
-            <a:off x="914400" y="4325112"/>
-            <a:ext cx="274320" cy="274320"/>
-          </a:xfrm>
-          <a:prstGeom prst="rect">
-            <a:avLst/>
-          </a:prstGeom>
-        </p:spPr>
-      </p:pic>
-      <p:sp>
-        <p:nvSpPr>
-          <p:cNvPr id="14" name="a2-b2"/>
-          <p:cNvSpPr txBox="1"/>
-          <p:nvPr/>
-        </p:nvSpPr>
-        <p:spPr>
-          <a:xfrm>
-            <a:off x="1371600" y="4251960"/>
-            <a:ext cx="4297680" cy="411480"/>
-          </a:xfrm>
-          <a:prstGeom prst="rect">
-            <a:avLst/>
-          </a:prstGeom>
-          <a:noFill/>
-          <a:ln/>
-        </p:spPr>
-        <p:txBody>
-          <a:bodyPr wrap="square" lIns="0" tIns="0" rIns="0" bIns="0" rtlCol="0" anchor="ctr"/>
-          <a:lstStyle/>
-          <a:p>
-            <a:pPr indent="0" marL="0">
-              <a:buNone/>
-            </a:pPr>
-            <a:r>
-              <a:rPr lang="en-US" sz="1600" dirty="0">
-                <a:solidFill>
-                  <a:schemeClr val="tx1"/>
-                </a:solidFill>
-              </a:rPr>
-              <a:t>Support tailored to growing businesses</a:t>
-            </a:r>
-            <a:endParaRPr lang="en-US" sz="1600" dirty="0"/>
-          </a:p>
-        </p:txBody>
-      </p:sp>
-      <p:sp>
-        <p:nvSpPr>
-          <p:cNvPr id="15" name="a3-c"/>
-          <p:cNvSpPr/>
-          <p:nvPr/>
-        </p:nvSpPr>
-        <p:spPr>
-          <a:xfrm>
-            <a:off x="6217920" y="1783080"/>
-            <a:ext cx="5394960" cy="3063240"/>
-          </a:xfrm>
-          <a:prstGeom prst="roundRect">
-            <a:avLst>
-              <a:gd name="adj" fmla="val 3582"/>
-            </a:avLst>
-          </a:prstGeom>
-          <a:solidFill>
-            <a:schemeClr val="bg1"/>
-          </a:solidFill>
-          <a:ln w="12700">
-            <a:solidFill>
-              <a:schemeClr val="accent4"/>
-            </a:solidFill>
-            <a:prstDash val="solid"/>
-          </a:ln>
-          <a:effectLst>
-            <a:outerShdw sx="100000" sy="100000" kx="0" ky="0" algn="bl" rotWithShape="0" blurRad="101600" dist="25400" dir="5400000">
-              <a:srgbClr val="1F2A6B">
-                <a:alpha val="12000"/>
-              </a:srgbClr>
-            </a:outerShdw>
-          </a:effectLst>
-        </p:spPr>
-      </p:sp>
-      <p:sp>
-        <p:nvSpPr>
-          <p:cNvPr id="16" name="a3-d"/>
-          <p:cNvSpPr/>
-          <p:nvPr/>
-        </p:nvSpPr>
-        <p:spPr>
-          <a:xfrm>
-            <a:off x="6537960" y="2103120"/>
-            <a:ext cx="868680" cy="868680"/>
-          </a:xfrm>
-          <a:prstGeom prst="ellipse">
-            <a:avLst/>
-          </a:prstGeom>
-          <a:solidFill>
-            <a:schemeClr val="accent2"/>
-          </a:solidFill>
-          <a:ln/>
-        </p:spPr>
-      </p:sp>
-      <p:pic>
-        <p:nvPicPr>
-          <p:cNvPr id="17" name="a3-d-i" descr="preencoded.png">    </p:cNvPr>
-          <p:cNvPicPr>
-            <a:picLocks noChangeAspect="1"/>
-          </p:cNvPicPr>
-          <p:nvPr/>
-        </p:nvPicPr>
-        <p:blipFill>
-          <a:blip r:embed="rId5"/>
-          <a:stretch>
-            <a:fillRect/>
-          </a:stretch>
-        </p:blipFill>
-        <p:spPr>
-          <a:xfrm>
-            <a:off x="6755130" y="2320290"/>
-            <a:ext cx="434340" cy="434340"/>
-          </a:xfrm>
-          <a:prstGeom prst="rect">
-            <a:avLst/>
-          </a:prstGeom>
-        </p:spPr>
-      </p:pic>
-      <p:sp>
-        <p:nvSpPr>
-          <p:cNvPr id="18" name="a3-h"/>
-          <p:cNvSpPr txBox="1"/>
-          <p:nvPr/>
-        </p:nvSpPr>
-        <p:spPr>
-          <a:xfrm>
-            <a:off x="7635240" y="2103120"/>
-            <a:ext cx="3749040" cy="502920"/>
-          </a:xfrm>
-          <a:prstGeom prst="rect">
-            <a:avLst/>
-          </a:prstGeom>
-          <a:noFill/>
-          <a:ln/>
-        </p:spPr>
-        <p:txBody>
-          <a:bodyPr wrap="square" lIns="0" tIns="0" rIns="0" bIns="0" rtlCol="0" anchor="ctr"/>
-          <a:lstStyle/>
-          <a:p>
-            <a:pPr indent="0" marL="0">
-              <a:buNone/>
-            </a:pPr>
-            <a:r>
-              <a:rPr lang="en-US" sz="2400" b="1" dirty="0">
-                <a:solidFill>
-                  <a:schemeClr val="tx2"/>
-                </a:solidFill>
-              </a:rPr>
-              <a:t>Singapore</a:t>
-            </a:r>
-            <a:endParaRPr lang="en-US" sz="2400" dirty="0"/>
-          </a:p>
-        </p:txBody>
-      </p:sp>
-      <p:sp>
-        <p:nvSpPr>
-          <p:cNvPr id="19" name="a3-s"/>
-          <p:cNvSpPr txBox="1"/>
-          <p:nvPr/>
-        </p:nvSpPr>
-        <p:spPr>
-          <a:xfrm>
-            <a:off x="7635240" y="2606040"/>
-            <a:ext cx="3749040" cy="320040"/>
+            <a:off x="6949440" y="2606040"/>
+            <a:ext cx="4389120" cy="320040"/>
           </a:xfrm>
           <a:prstGeom prst="rect">
             <a:avLst/>
@@ -24150,49 +25854,47 @@
             <a:r>
               <a:rPr lang="en-US" sz="1300" b="1" spc="200" kern="0" dirty="0">
                 <a:solidFill>
-                  <a:schemeClr val="accent1"/>
+                  <a:schemeClr val="accent3"/>
                 </a:solidFill>
               </a:rPr>
-              <a:t>ACCOUNTING &amp; REPORTING FOR SMEs</a:t>
+              <a:t>WHAT OUR CLIENTS GET</a:t>
             </a:r>
             <a:endParaRPr lang="en-US" sz="1300" dirty="0"/>
           </a:p>
         </p:txBody>
       </p:sp>
-      <p:pic>
-        <p:nvPicPr>
-          <p:cNvPr id="20" name="a3-k0" descr="preencoded.png">    </p:cNvPr>
-          <p:cNvPicPr>
-            <a:picLocks noChangeAspect="1"/>
-          </p:cNvPicPr>
-          <p:nvPr/>
-        </p:nvPicPr>
-        <p:blipFill>
-          <a:blip r:embed="rId6"/>
-          <a:stretch>
-            <a:fillRect/>
-          </a:stretch>
-        </p:blipFill>
-        <p:spPr>
-          <a:xfrm>
-            <a:off x="6583680" y="3319272"/>
-            <a:ext cx="274320" cy="274320"/>
-          </a:xfrm>
-          <a:prstGeom prst="rect">
-            <a:avLst/>
-          </a:prstGeom>
-        </p:spPr>
-      </p:pic>
-      <p:sp>
-        <p:nvSpPr>
-          <p:cNvPr id="21" name="a3-b0"/>
+      <p:sp>
+        <p:nvSpPr>
+          <p:cNvPr id="17" name="a6-c0"/>
+          <p:cNvSpPr/>
+          <p:nvPr/>
+        </p:nvSpPr>
+        <p:spPr>
+          <a:xfrm>
+            <a:off x="6949440" y="2971800"/>
+            <a:ext cx="4297680" cy="603504"/>
+          </a:xfrm>
+          <a:prstGeom prst="roundRect">
+            <a:avLst>
+              <a:gd name="adj" fmla="val 18182"/>
+            </a:avLst>
+          </a:prstGeom>
+          <a:solidFill>
+            <a:schemeClr val="bg1"/>
+          </a:solidFill>
+          <a:ln/>
+        </p:spPr>
+      </p:sp>
+      <p:sp>
+        <p:nvSpPr>
+          <p:cNvPr id="18" name="a6-n0"/>
           <p:cNvSpPr txBox="1"/>
           <p:nvPr/>
         </p:nvSpPr>
         <p:spPr>
           <a:xfrm>
-            <a:off x="7040880" y="3246120"/>
-            <a:ext cx="4297680" cy="411480"/>
+            <a:off x="7178040" y="2971800"/>
+            <a:ext cx="3931920" cy="603504"/>
           </a:xfrm>
           <a:prstGeom prst="rect">
             <a:avLst/>
@@ -24208,51 +25910,49 @@
               <a:buNone/>
             </a:pPr>
             <a:r>
-              <a:rPr lang="en-US" sz="1600" dirty="0">
+              <a:rPr lang="en-US" sz="1500" b="1" dirty="0">
                 <a:solidFill>
-                  <a:schemeClr val="tx1"/>
+                  <a:schemeClr val="tx2"/>
                 </a:solidFill>
               </a:rPr>
-              <a:t>Bookkeeping in QuickBooks and Xero</a:t>
+              <a:t>One dedicated team for their tax needs</a:t>
             </a:r>
-            <a:endParaRPr lang="en-US" sz="1600" dirty="0"/>
+            <a:endParaRPr lang="en-US" sz="1500" dirty="0"/>
           </a:p>
         </p:txBody>
       </p:sp>
-      <p:pic>
-        <p:nvPicPr>
-          <p:cNvPr id="22" name="a3-k1" descr="preencoded.png">    </p:cNvPr>
-          <p:cNvPicPr>
-            <a:picLocks noChangeAspect="1"/>
-          </p:cNvPicPr>
-          <p:nvPr/>
-        </p:nvPicPr>
-        <p:blipFill>
-          <a:blip r:embed="rId7"/>
-          <a:stretch>
-            <a:fillRect/>
-          </a:stretch>
-        </p:blipFill>
-        <p:spPr>
-          <a:xfrm>
-            <a:off x="6583680" y="3822192"/>
-            <a:ext cx="274320" cy="274320"/>
-          </a:xfrm>
-          <a:prstGeom prst="rect">
-            <a:avLst/>
-          </a:prstGeom>
-        </p:spPr>
-      </p:pic>
-      <p:sp>
-        <p:nvSpPr>
-          <p:cNvPr id="23" name="a3-b1"/>
+      <p:sp>
+        <p:nvSpPr>
+          <p:cNvPr id="19" name="a6-c1"/>
+          <p:cNvSpPr/>
+          <p:nvPr/>
+        </p:nvSpPr>
+        <p:spPr>
+          <a:xfrm>
+            <a:off x="6949440" y="3703320"/>
+            <a:ext cx="4297680" cy="603504"/>
+          </a:xfrm>
+          <a:prstGeom prst="roundRect">
+            <a:avLst>
+              <a:gd name="adj" fmla="val 18182"/>
+            </a:avLst>
+          </a:prstGeom>
+          <a:solidFill>
+            <a:schemeClr val="bg1"/>
+          </a:solidFill>
+          <a:ln/>
+        </p:spPr>
+      </p:sp>
+      <p:sp>
+        <p:nvSpPr>
+          <p:cNvPr id="20" name="a6-n1"/>
           <p:cNvSpPr txBox="1"/>
           <p:nvPr/>
         </p:nvSpPr>
         <p:spPr>
           <a:xfrm>
-            <a:off x="7040880" y="3749040"/>
-            <a:ext cx="4297680" cy="411480"/>
+            <a:off x="7178040" y="3703320"/>
+            <a:ext cx="3931920" cy="603504"/>
           </a:xfrm>
           <a:prstGeom prst="rect">
             <a:avLst/>
@@ -24268,51 +25968,49 @@
               <a:buNone/>
             </a:pPr>
             <a:r>
-              <a:rPr lang="en-US" sz="1600" dirty="0">
+              <a:rPr lang="en-US" sz="1500" b="1" dirty="0">
                 <a:solidFill>
-                  <a:schemeClr val="tx1"/>
+                  <a:schemeClr val="tx2"/>
                 </a:solidFill>
               </a:rPr>
-              <a:t>Accounting records kept accurate and up to date</a:t>
+              <a:t>Clear answers in plain language</a:t>
             </a:r>
-            <a:endParaRPr lang="en-US" sz="1600" dirty="0"/>
+            <a:endParaRPr lang="en-US" sz="1500" dirty="0"/>
           </a:p>
         </p:txBody>
       </p:sp>
-      <p:pic>
-        <p:nvPicPr>
-          <p:cNvPr id="24" name="a3-k2" descr="preencoded.png">    </p:cNvPr>
-          <p:cNvPicPr>
-            <a:picLocks noChangeAspect="1"/>
-          </p:cNvPicPr>
-          <p:nvPr/>
-        </p:nvPicPr>
-        <p:blipFill>
-          <a:blip r:embed="rId8"/>
-          <a:stretch>
-            <a:fillRect/>
-          </a:stretch>
-        </p:blipFill>
-        <p:spPr>
-          <a:xfrm>
-            <a:off x="6583680" y="4325112"/>
-            <a:ext cx="274320" cy="274320"/>
-          </a:xfrm>
-          <a:prstGeom prst="rect">
-            <a:avLst/>
-          </a:prstGeom>
-        </p:spPr>
-      </p:pic>
-      <p:sp>
-        <p:nvSpPr>
-          <p:cNvPr id="25" name="a3-b2"/>
+      <p:sp>
+        <p:nvSpPr>
+          <p:cNvPr id="21" name="a6-c2"/>
+          <p:cNvSpPr/>
+          <p:nvPr/>
+        </p:nvSpPr>
+        <p:spPr>
+          <a:xfrm>
+            <a:off x="6949440" y="4434840"/>
+            <a:ext cx="4297680" cy="603504"/>
+          </a:xfrm>
+          <a:prstGeom prst="roundRect">
+            <a:avLst>
+              <a:gd name="adj" fmla="val 18182"/>
+            </a:avLst>
+          </a:prstGeom>
+          <a:solidFill>
+            <a:schemeClr val="bg1"/>
+          </a:solidFill>
+          <a:ln/>
+        </p:spPr>
+      </p:sp>
+      <p:sp>
+        <p:nvSpPr>
+          <p:cNvPr id="22" name="a6-n2"/>
           <p:cNvSpPr txBox="1"/>
           <p:nvPr/>
         </p:nvSpPr>
         <p:spPr>
           <a:xfrm>
-            <a:off x="7040880" y="4251960"/>
-            <a:ext cx="4297680" cy="411480"/>
+            <a:off x="7178040" y="4434840"/>
+            <a:ext cx="3931920" cy="603504"/>
           </a:xfrm>
           <a:prstGeom prst="rect">
             <a:avLst/>
@@ -24328,127 +26026,14 @@
               <a:buNone/>
             </a:pPr>
             <a:r>
-              <a:rPr lang="en-US" sz="1600" dirty="0">
-                <a:solidFill>
-                  <a:schemeClr val="tx1"/>
-                </a:solidFill>
-              </a:rPr>
-              <a:t>Annual financial statements prepared for the AGM</a:t>
-            </a:r>
-            <a:endParaRPr lang="en-US" sz="1600" dirty="0"/>
-          </a:p>
-        </p:txBody>
-      </p:sp>
-      <p:sp>
-        <p:nvSpPr>
-          <p:cNvPr id="26" name="a4-k"/>
-          <p:cNvSpPr/>
-          <p:nvPr/>
-        </p:nvSpPr>
-        <p:spPr>
-          <a:xfrm>
-            <a:off x="548640" y="5120640"/>
-            <a:ext cx="11064240" cy="868680"/>
-          </a:xfrm>
-          <a:prstGeom prst="roundRect">
-            <a:avLst>
-              <a:gd name="adj" fmla="val 12632"/>
-            </a:avLst>
-          </a:prstGeom>
-          <a:solidFill>
-            <a:schemeClr val="bg2"/>
-          </a:solidFill>
-          <a:ln/>
-        </p:spPr>
-      </p:sp>
-      <p:sp>
-        <p:nvSpPr>
-          <p:cNvPr id="27" name="a4-d"/>
-          <p:cNvSpPr/>
-          <p:nvPr/>
-        </p:nvSpPr>
-        <p:spPr>
-          <a:xfrm>
-            <a:off x="777240" y="5230368"/>
-            <a:ext cx="640080" cy="640080"/>
-          </a:xfrm>
-          <a:prstGeom prst="ellipse">
-            <a:avLst/>
-          </a:prstGeom>
-          <a:solidFill>
-            <a:schemeClr val="accent1"/>
-          </a:solidFill>
-          <a:ln/>
-        </p:spPr>
-      </p:sp>
-      <p:pic>
-        <p:nvPicPr>
-          <p:cNvPr id="28" name="a4-d-i" descr="preencoded.png">    </p:cNvPr>
-          <p:cNvPicPr>
-            <a:picLocks noChangeAspect="1"/>
-          </p:cNvPicPr>
-          <p:nvPr/>
-        </p:nvPicPr>
-        <p:blipFill>
-          <a:blip r:embed="rId9"/>
-          <a:stretch>
-            <a:fillRect/>
-          </a:stretch>
-        </p:blipFill>
-        <p:spPr>
-          <a:xfrm>
-            <a:off x="937260" y="5390388"/>
-            <a:ext cx="320040" cy="320040"/>
-          </a:xfrm>
-          <a:prstGeom prst="rect">
-            <a:avLst/>
-          </a:prstGeom>
-        </p:spPr>
-      </p:pic>
-      <p:sp>
-        <p:nvSpPr>
-          <p:cNvPr id="29" name="a4-t"/>
-          <p:cNvSpPr txBox="1"/>
-          <p:nvPr/>
-        </p:nvSpPr>
-        <p:spPr>
-          <a:xfrm>
-            <a:off x="1600200" y="5120640"/>
-            <a:ext cx="9875520" cy="868680"/>
-          </a:xfrm>
-          <a:prstGeom prst="rect">
-            <a:avLst/>
-          </a:prstGeom>
-          <a:noFill/>
-          <a:ln/>
-        </p:spPr>
-        <p:txBody>
-          <a:bodyPr wrap="square" lIns="0" tIns="0" rIns="0" bIns="0" rtlCol="0" anchor="ctr"/>
-          <a:lstStyle/>
-          <a:p>
-            <a:pPr indent="0" marL="0">
-              <a:buNone/>
-            </a:pPr>
-            <a:r>
-              <a:rPr lang="en-US" sz="1600" b="1" dirty="0">
+              <a:rPr lang="en-US" sz="1500" b="1" dirty="0">
                 <a:solidFill>
                   <a:schemeClr val="tx2"/>
                 </a:solidFill>
               </a:rPr>
-              <a:t>Same team, same standards: </a:t>
+              <a:t>Deadlines tracked and met</a:t>
             </a:r>
-            <a:pPr indent="0" marL="0">
-              <a:buNone/>
-            </a:pPr>
-            <a:r>
-              <a:rPr lang="en-US" sz="1600" dirty="0">
-                <a:solidFill>
-                  <a:schemeClr val="tx1"/>
-                </a:solidFill>
-              </a:rPr>
-              <a:t>the same care and quality our clients rely on, in every market we serve.</a:t>
-            </a:r>
-            <a:endParaRPr lang="en-US" sz="1600" dirty="0"/>
+            <a:endParaRPr lang="en-US" sz="1500" dirty="0"/>
           </a:p>
         </p:txBody>
       </p:sp>
@@ -24567,7 +26152,7 @@
                           </p:cTn>
                         </p:par>
                         <p:par>
-                          <p:cTn id="41" fill="hold">
+                          <p:cTn id="17" fill="hold">
                             <p:stCondLst>
                               <p:cond delay="750"/>
                             </p:stCondLst>
@@ -24677,674 +26262,114 @@
                                   </p:childTnLst>
                                 </p:cTn>
                               </p:par>
-                              <p:par>
-                                <p:cTn id="17" presetID="10" presetClass="entr" presetSubtype="0" fill="hold" grpId="0" nodeType="withEffect">
-                                  <p:stCondLst>
-                                    <p:cond delay="0"/>
-                                  </p:stCondLst>
-                                  <p:childTnLst>
-                                    <p:set>
-                                      <p:cBhvr>
-                                        <p:cTn id="18" dur="1" fill="hold">
-                                          <p:stCondLst>
-                                            <p:cond delay="0"/>
-                                          </p:stCondLst>
-                                        </p:cTn>
-                                        <p:tgtEl>
-                                          <p:spTgt spid="7"/>
-                                        </p:tgtEl>
-                                        <p:attrNameLst>
-                                          <p:attrName>style.visibility</p:attrName>
-                                        </p:attrNameLst>
-                                      </p:cBhvr>
-                                      <p:to>
-                                        <p:strVal val="visible"/>
-                                      </p:to>
-                                    </p:set>
-                                    <p:animEffect transition="in" filter="fade">
-                                      <p:cBhvr>
-                                        <p:cTn id="19" dur="500"/>
-                                        <p:tgtEl>
-                                          <p:spTgt spid="7"/>
-                                        </p:tgtEl>
-                                      </p:cBhvr>
-                                    </p:animEffect>
-                                  </p:childTnLst>
-                                </p:cTn>
-                              </p:par>
-                              <p:par>
-                                <p:cTn id="20" presetID="10" presetClass="entr" presetSubtype="0" fill="hold" grpId="0" nodeType="withEffect">
-                                  <p:stCondLst>
-                                    <p:cond delay="0"/>
-                                  </p:stCondLst>
-                                  <p:childTnLst>
-                                    <p:set>
-                                      <p:cBhvr>
-                                        <p:cTn id="21" dur="1" fill="hold">
-                                          <p:stCondLst>
-                                            <p:cond delay="0"/>
-                                          </p:stCondLst>
-                                        </p:cTn>
-                                        <p:tgtEl>
-                                          <p:spTgt spid="8"/>
-                                        </p:tgtEl>
-                                        <p:attrNameLst>
-                                          <p:attrName>style.visibility</p:attrName>
-                                        </p:attrNameLst>
-                                      </p:cBhvr>
-                                      <p:to>
-                                        <p:strVal val="visible"/>
-                                      </p:to>
-                                    </p:set>
-                                    <p:animEffect transition="in" filter="fade">
-                                      <p:cBhvr>
-                                        <p:cTn id="22" dur="500"/>
-                                        <p:tgtEl>
-                                          <p:spTgt spid="8"/>
-                                        </p:tgtEl>
-                                      </p:cBhvr>
-                                    </p:animEffect>
-                                  </p:childTnLst>
-                                </p:cTn>
-                              </p:par>
-                              <p:par>
-                                <p:cTn id="23" presetID="10" presetClass="entr" presetSubtype="0" fill="hold" grpId="0" nodeType="withEffect">
-                                  <p:stCondLst>
-                                    <p:cond delay="0"/>
-                                  </p:stCondLst>
-                                  <p:childTnLst>
-                                    <p:set>
-                                      <p:cBhvr>
-                                        <p:cTn id="24" dur="1" fill="hold">
-                                          <p:stCondLst>
-                                            <p:cond delay="0"/>
-                                          </p:stCondLst>
-                                        </p:cTn>
-                                        <p:tgtEl>
-                                          <p:spTgt spid="9"/>
-                                        </p:tgtEl>
-                                        <p:attrNameLst>
-                                          <p:attrName>style.visibility</p:attrName>
-                                        </p:attrNameLst>
-                                      </p:cBhvr>
-                                      <p:to>
-                                        <p:strVal val="visible"/>
-                                      </p:to>
-                                    </p:set>
-                                    <p:animEffect transition="in" filter="fade">
-                                      <p:cBhvr>
-                                        <p:cTn id="25" dur="500"/>
-                                        <p:tgtEl>
-                                          <p:spTgt spid="9"/>
-                                        </p:tgtEl>
-                                      </p:cBhvr>
-                                    </p:animEffect>
-                                  </p:childTnLst>
-                                </p:cTn>
-                              </p:par>
-                              <p:par>
-                                <p:cTn id="26" presetID="10" presetClass="entr" presetSubtype="0" fill="hold" grpId="0" nodeType="withEffect">
-                                  <p:stCondLst>
-                                    <p:cond delay="0"/>
-                                  </p:stCondLst>
-                                  <p:childTnLst>
-                                    <p:set>
-                                      <p:cBhvr>
-                                        <p:cTn id="27" dur="1" fill="hold">
-                                          <p:stCondLst>
-                                            <p:cond delay="0"/>
-                                          </p:stCondLst>
-                                        </p:cTn>
-                                        <p:tgtEl>
-                                          <p:spTgt spid="10"/>
-                                        </p:tgtEl>
-                                        <p:attrNameLst>
-                                          <p:attrName>style.visibility</p:attrName>
-                                        </p:attrNameLst>
-                                      </p:cBhvr>
-                                      <p:to>
-                                        <p:strVal val="visible"/>
-                                      </p:to>
-                                    </p:set>
-                                    <p:animEffect transition="in" filter="fade">
-                                      <p:cBhvr>
-                                        <p:cTn id="28" dur="500"/>
-                                        <p:tgtEl>
-                                          <p:spTgt spid="10"/>
-                                        </p:tgtEl>
-                                      </p:cBhvr>
-                                    </p:animEffect>
-                                  </p:childTnLst>
-                                </p:cTn>
-                              </p:par>
-                              <p:par>
-                                <p:cTn id="29" presetID="10" presetClass="entr" presetSubtype="0" fill="hold" grpId="0" nodeType="withEffect">
-                                  <p:stCondLst>
-                                    <p:cond delay="0"/>
-                                  </p:stCondLst>
-                                  <p:childTnLst>
-                                    <p:set>
-                                      <p:cBhvr>
-                                        <p:cTn id="30" dur="1" fill="hold">
-                                          <p:stCondLst>
-                                            <p:cond delay="0"/>
-                                          </p:stCondLst>
-                                        </p:cTn>
-                                        <p:tgtEl>
-                                          <p:spTgt spid="11"/>
-                                        </p:tgtEl>
-                                        <p:attrNameLst>
-                                          <p:attrName>style.visibility</p:attrName>
-                                        </p:attrNameLst>
-                                      </p:cBhvr>
-                                      <p:to>
-                                        <p:strVal val="visible"/>
-                                      </p:to>
-                                    </p:set>
-                                    <p:animEffect transition="in" filter="fade">
-                                      <p:cBhvr>
-                                        <p:cTn id="31" dur="500"/>
-                                        <p:tgtEl>
-                                          <p:spTgt spid="11"/>
-                                        </p:tgtEl>
-                                      </p:cBhvr>
-                                    </p:animEffect>
-                                  </p:childTnLst>
-                                </p:cTn>
-                              </p:par>
-                              <p:par>
-                                <p:cTn id="32" presetID="10" presetClass="entr" presetSubtype="0" fill="hold" grpId="0" nodeType="withEffect">
-                                  <p:stCondLst>
-                                    <p:cond delay="0"/>
-                                  </p:stCondLst>
-                                  <p:childTnLst>
-                                    <p:set>
-                                      <p:cBhvr>
-                                        <p:cTn id="33" dur="1" fill="hold">
-                                          <p:stCondLst>
-                                            <p:cond delay="0"/>
-                                          </p:stCondLst>
-                                        </p:cTn>
-                                        <p:tgtEl>
-                                          <p:spTgt spid="12"/>
-                                        </p:tgtEl>
-                                        <p:attrNameLst>
-                                          <p:attrName>style.visibility</p:attrName>
-                                        </p:attrNameLst>
-                                      </p:cBhvr>
-                                      <p:to>
-                                        <p:strVal val="visible"/>
-                                      </p:to>
-                                    </p:set>
-                                    <p:animEffect transition="in" filter="fade">
-                                      <p:cBhvr>
-                                        <p:cTn id="34" dur="500"/>
-                                        <p:tgtEl>
-                                          <p:spTgt spid="12"/>
-                                        </p:tgtEl>
-                                      </p:cBhvr>
-                                    </p:animEffect>
-                                  </p:childTnLst>
-                                </p:cTn>
-                              </p:par>
-                              <p:par>
-                                <p:cTn id="35" presetID="10" presetClass="entr" presetSubtype="0" fill="hold" grpId="0" nodeType="withEffect">
-                                  <p:stCondLst>
-                                    <p:cond delay="0"/>
-                                  </p:stCondLst>
-                                  <p:childTnLst>
-                                    <p:set>
-                                      <p:cBhvr>
-                                        <p:cTn id="36" dur="1" fill="hold">
-                                          <p:stCondLst>
-                                            <p:cond delay="0"/>
-                                          </p:stCondLst>
-                                        </p:cTn>
-                                        <p:tgtEl>
-                                          <p:spTgt spid="13"/>
-                                        </p:tgtEl>
-                                        <p:attrNameLst>
-                                          <p:attrName>style.visibility</p:attrName>
-                                        </p:attrNameLst>
-                                      </p:cBhvr>
-                                      <p:to>
-                                        <p:strVal val="visible"/>
-                                      </p:to>
-                                    </p:set>
-                                    <p:animEffect transition="in" filter="fade">
-                                      <p:cBhvr>
-                                        <p:cTn id="37" dur="500"/>
-                                        <p:tgtEl>
-                                          <p:spTgt spid="13"/>
-                                        </p:tgtEl>
-                                      </p:cBhvr>
-                                    </p:animEffect>
-                                  </p:childTnLst>
-                                </p:cTn>
-                              </p:par>
-                              <p:par>
-                                <p:cTn id="38" presetID="10" presetClass="entr" presetSubtype="0" fill="hold" grpId="0" nodeType="withEffect">
-                                  <p:stCondLst>
-                                    <p:cond delay="0"/>
-                                  </p:stCondLst>
-                                  <p:childTnLst>
-                                    <p:set>
-                                      <p:cBhvr>
-                                        <p:cTn id="39" dur="1" fill="hold">
-                                          <p:stCondLst>
-                                            <p:cond delay="0"/>
-                                          </p:stCondLst>
-                                        </p:cTn>
-                                        <p:tgtEl>
-                                          <p:spTgt spid="14"/>
-                                        </p:tgtEl>
-                                        <p:attrNameLst>
-                                          <p:attrName>style.visibility</p:attrName>
-                                        </p:attrNameLst>
-                                      </p:cBhvr>
-                                      <p:to>
-                                        <p:strVal val="visible"/>
-                                      </p:to>
-                                    </p:set>
-                                    <p:animEffect transition="in" filter="fade">
-                                      <p:cBhvr>
-                                        <p:cTn id="40" dur="500"/>
-                                        <p:tgtEl>
-                                          <p:spTgt spid="14"/>
-                                        </p:tgtEl>
-                                      </p:cBhvr>
-                                    </p:animEffect>
-                                  </p:childTnLst>
-                                </p:cTn>
-                              </p:par>
                             </p:childTnLst>
                           </p:cTn>
                         </p:par>
                         <p:par>
-                          <p:cTn id="75" fill="hold">
+                          <p:cTn id="27" fill="hold">
                             <p:stCondLst>
                               <p:cond delay="1200"/>
                             </p:stCondLst>
                             <p:childTnLst>
                               <p:par>
-                                <p:cTn id="42" presetID="10" presetClass="entr" presetSubtype="0" fill="hold" grpId="0" nodeType="afterEffect">
-                                  <p:stCondLst>
-                                    <p:cond delay="0"/>
-                                  </p:stCondLst>
-                                  <p:childTnLst>
-                                    <p:set>
-                                      <p:cBhvr>
-                                        <p:cTn id="43" dur="1" fill="hold">
-                                          <p:stCondLst>
-                                            <p:cond delay="0"/>
-                                          </p:stCondLst>
-                                        </p:cTn>
-                                        <p:tgtEl>
-                                          <p:spTgt spid="15"/>
-                                        </p:tgtEl>
-                                        <p:attrNameLst>
-                                          <p:attrName>style.visibility</p:attrName>
-                                        </p:attrNameLst>
-                                      </p:cBhvr>
-                                      <p:to>
-                                        <p:strVal val="visible"/>
-                                      </p:to>
-                                    </p:set>
-                                    <p:animEffect transition="in" filter="fade">
-                                      <p:cBhvr>
-                                        <p:cTn id="44" dur="500"/>
-                                        <p:tgtEl>
-                                          <p:spTgt spid="15"/>
-                                        </p:tgtEl>
-                                      </p:cBhvr>
-                                    </p:animEffect>
-                                  </p:childTnLst>
-                                </p:cTn>
-                              </p:par>
-                              <p:par>
-                                <p:cTn id="45" presetID="10" presetClass="entr" presetSubtype="0" fill="hold" grpId="0" nodeType="withEffect">
-                                  <p:stCondLst>
-                                    <p:cond delay="0"/>
-                                  </p:stCondLst>
-                                  <p:childTnLst>
-                                    <p:set>
-                                      <p:cBhvr>
-                                        <p:cTn id="46" dur="1" fill="hold">
-                                          <p:stCondLst>
-                                            <p:cond delay="0"/>
-                                          </p:stCondLst>
-                                        </p:cTn>
-                                        <p:tgtEl>
-                                          <p:spTgt spid="16"/>
-                                        </p:tgtEl>
-                                        <p:attrNameLst>
-                                          <p:attrName>style.visibility</p:attrName>
-                                        </p:attrNameLst>
-                                      </p:cBhvr>
-                                      <p:to>
-                                        <p:strVal val="visible"/>
-                                      </p:to>
-                                    </p:set>
-                                    <p:animEffect transition="in" filter="fade">
-                                      <p:cBhvr>
-                                        <p:cTn id="47" dur="500"/>
-                                        <p:tgtEl>
-                                          <p:spTgt spid="16"/>
-                                        </p:tgtEl>
-                                      </p:cBhvr>
-                                    </p:animEffect>
-                                  </p:childTnLst>
-                                </p:cTn>
-                              </p:par>
-                              <p:par>
-                                <p:cTn id="48" presetID="10" presetClass="entr" presetSubtype="0" fill="hold" grpId="0" nodeType="withEffect">
-                                  <p:stCondLst>
-                                    <p:cond delay="0"/>
-                                  </p:stCondLst>
-                                  <p:childTnLst>
-                                    <p:set>
-                                      <p:cBhvr>
-                                        <p:cTn id="49" dur="1" fill="hold">
-                                          <p:stCondLst>
-                                            <p:cond delay="0"/>
-                                          </p:stCondLst>
-                                        </p:cTn>
-                                        <p:tgtEl>
-                                          <p:spTgt spid="17"/>
-                                        </p:tgtEl>
-                                        <p:attrNameLst>
-                                          <p:attrName>style.visibility</p:attrName>
-                                        </p:attrNameLst>
-                                      </p:cBhvr>
-                                      <p:to>
-                                        <p:strVal val="visible"/>
-                                      </p:to>
-                                    </p:set>
-                                    <p:animEffect transition="in" filter="fade">
-                                      <p:cBhvr>
-                                        <p:cTn id="50" dur="500"/>
-                                        <p:tgtEl>
-                                          <p:spTgt spid="17"/>
-                                        </p:tgtEl>
-                                      </p:cBhvr>
-                                    </p:animEffect>
-                                  </p:childTnLst>
-                                </p:cTn>
-                              </p:par>
-                              <p:par>
-                                <p:cTn id="51" presetID="10" presetClass="entr" presetSubtype="0" fill="hold" grpId="0" nodeType="withEffect">
-                                  <p:stCondLst>
-                                    <p:cond delay="0"/>
-                                  </p:stCondLst>
-                                  <p:childTnLst>
-                                    <p:set>
-                                      <p:cBhvr>
-                                        <p:cTn id="52" dur="1" fill="hold">
-                                          <p:stCondLst>
-                                            <p:cond delay="0"/>
-                                          </p:stCondLst>
-                                        </p:cTn>
-                                        <p:tgtEl>
-                                          <p:spTgt spid="18"/>
-                                        </p:tgtEl>
-                                        <p:attrNameLst>
-                                          <p:attrName>style.visibility</p:attrName>
-                                        </p:attrNameLst>
-                                      </p:cBhvr>
-                                      <p:to>
-                                        <p:strVal val="visible"/>
-                                      </p:to>
-                                    </p:set>
-                                    <p:animEffect transition="in" filter="fade">
-                                      <p:cBhvr>
-                                        <p:cTn id="53" dur="500"/>
-                                        <p:tgtEl>
-                                          <p:spTgt spid="18"/>
-                                        </p:tgtEl>
-                                      </p:cBhvr>
-                                    </p:animEffect>
-                                  </p:childTnLst>
-                                </p:cTn>
-                              </p:par>
-                              <p:par>
-                                <p:cTn id="54" presetID="10" presetClass="entr" presetSubtype="0" fill="hold" grpId="0" nodeType="withEffect">
-                                  <p:stCondLst>
-                                    <p:cond delay="0"/>
-                                  </p:stCondLst>
-                                  <p:childTnLst>
-                                    <p:set>
-                                      <p:cBhvr>
-                                        <p:cTn id="55" dur="1" fill="hold">
-                                          <p:stCondLst>
-                                            <p:cond delay="0"/>
-                                          </p:stCondLst>
-                                        </p:cTn>
-                                        <p:tgtEl>
-                                          <p:spTgt spid="19"/>
-                                        </p:tgtEl>
-                                        <p:attrNameLst>
-                                          <p:attrName>style.visibility</p:attrName>
-                                        </p:attrNameLst>
-                                      </p:cBhvr>
-                                      <p:to>
-                                        <p:strVal val="visible"/>
-                                      </p:to>
-                                    </p:set>
-                                    <p:animEffect transition="in" filter="fade">
-                                      <p:cBhvr>
-                                        <p:cTn id="56" dur="500"/>
-                                        <p:tgtEl>
-                                          <p:spTgt spid="19"/>
-                                        </p:tgtEl>
-                                      </p:cBhvr>
-                                    </p:animEffect>
-                                  </p:childTnLst>
-                                </p:cTn>
-                              </p:par>
-                              <p:par>
-                                <p:cTn id="57" presetID="10" presetClass="entr" presetSubtype="0" fill="hold" grpId="0" nodeType="withEffect">
-                                  <p:stCondLst>
-                                    <p:cond delay="0"/>
-                                  </p:stCondLst>
-                                  <p:childTnLst>
-                                    <p:set>
-                                      <p:cBhvr>
-                                        <p:cTn id="58" dur="1" fill="hold">
-                                          <p:stCondLst>
-                                            <p:cond delay="0"/>
-                                          </p:stCondLst>
-                                        </p:cTn>
-                                        <p:tgtEl>
-                                          <p:spTgt spid="20"/>
-                                        </p:tgtEl>
-                                        <p:attrNameLst>
-                                          <p:attrName>style.visibility</p:attrName>
-                                        </p:attrNameLst>
-                                      </p:cBhvr>
-                                      <p:to>
-                                        <p:strVal val="visible"/>
-                                      </p:to>
-                                    </p:set>
-                                    <p:animEffect transition="in" filter="fade">
-                                      <p:cBhvr>
-                                        <p:cTn id="59" dur="500"/>
-                                        <p:tgtEl>
-                                          <p:spTgt spid="20"/>
-                                        </p:tgtEl>
-                                      </p:cBhvr>
-                                    </p:animEffect>
-                                  </p:childTnLst>
-                                </p:cTn>
-                              </p:par>
-                              <p:par>
-                                <p:cTn id="60" presetID="10" presetClass="entr" presetSubtype="0" fill="hold" grpId="0" nodeType="withEffect">
-                                  <p:stCondLst>
-                                    <p:cond delay="0"/>
-                                  </p:stCondLst>
-                                  <p:childTnLst>
-                                    <p:set>
-                                      <p:cBhvr>
-                                        <p:cTn id="61" dur="1" fill="hold">
-                                          <p:stCondLst>
-                                            <p:cond delay="0"/>
-                                          </p:stCondLst>
-                                        </p:cTn>
-                                        <p:tgtEl>
-                                          <p:spTgt spid="21"/>
-                                        </p:tgtEl>
-                                        <p:attrNameLst>
-                                          <p:attrName>style.visibility</p:attrName>
-                                        </p:attrNameLst>
-                                      </p:cBhvr>
-                                      <p:to>
-                                        <p:strVal val="visible"/>
-                                      </p:to>
-                                    </p:set>
-                                    <p:animEffect transition="in" filter="fade">
-                                      <p:cBhvr>
-                                        <p:cTn id="62" dur="500"/>
-                                        <p:tgtEl>
-                                          <p:spTgt spid="21"/>
-                                        </p:tgtEl>
-                                      </p:cBhvr>
-                                    </p:animEffect>
-                                  </p:childTnLst>
-                                </p:cTn>
-                              </p:par>
-                              <p:par>
-                                <p:cTn id="63" presetID="10" presetClass="entr" presetSubtype="0" fill="hold" grpId="0" nodeType="withEffect">
-                                  <p:stCondLst>
-                                    <p:cond delay="0"/>
-                                  </p:stCondLst>
-                                  <p:childTnLst>
-                                    <p:set>
-                                      <p:cBhvr>
-                                        <p:cTn id="64" dur="1" fill="hold">
-                                          <p:stCondLst>
-                                            <p:cond delay="0"/>
-                                          </p:stCondLst>
-                                        </p:cTn>
-                                        <p:tgtEl>
-                                          <p:spTgt spid="22"/>
-                                        </p:tgtEl>
-                                        <p:attrNameLst>
-                                          <p:attrName>style.visibility</p:attrName>
-                                        </p:attrNameLst>
-                                      </p:cBhvr>
-                                      <p:to>
-                                        <p:strVal val="visible"/>
-                                      </p:to>
-                                    </p:set>
-                                    <p:animEffect transition="in" filter="fade">
-                                      <p:cBhvr>
-                                        <p:cTn id="65" dur="500"/>
-                                        <p:tgtEl>
-                                          <p:spTgt spid="22"/>
-                                        </p:tgtEl>
-                                      </p:cBhvr>
-                                    </p:animEffect>
-                                  </p:childTnLst>
-                                </p:cTn>
-                              </p:par>
-                              <p:par>
-                                <p:cTn id="66" presetID="10" presetClass="entr" presetSubtype="0" fill="hold" grpId="0" nodeType="withEffect">
-                                  <p:stCondLst>
-                                    <p:cond delay="0"/>
-                                  </p:stCondLst>
-                                  <p:childTnLst>
-                                    <p:set>
-                                      <p:cBhvr>
-                                        <p:cTn id="67" dur="1" fill="hold">
-                                          <p:stCondLst>
-                                            <p:cond delay="0"/>
-                                          </p:stCondLst>
-                                        </p:cTn>
-                                        <p:tgtEl>
-                                          <p:spTgt spid="23"/>
-                                        </p:tgtEl>
-                                        <p:attrNameLst>
-                                          <p:attrName>style.visibility</p:attrName>
-                                        </p:attrNameLst>
-                                      </p:cBhvr>
-                                      <p:to>
-                                        <p:strVal val="visible"/>
-                                      </p:to>
-                                    </p:set>
-                                    <p:animEffect transition="in" filter="fade">
-                                      <p:cBhvr>
-                                        <p:cTn id="68" dur="500"/>
-                                        <p:tgtEl>
-                                          <p:spTgt spid="23"/>
-                                        </p:tgtEl>
-                                      </p:cBhvr>
-                                    </p:animEffect>
-                                  </p:childTnLst>
-                                </p:cTn>
-                              </p:par>
-                              <p:par>
-                                <p:cTn id="69" presetID="10" presetClass="entr" presetSubtype="0" fill="hold" grpId="0" nodeType="withEffect">
-                                  <p:stCondLst>
-                                    <p:cond delay="0"/>
-                                  </p:stCondLst>
-                                  <p:childTnLst>
-                                    <p:set>
-                                      <p:cBhvr>
-                                        <p:cTn id="70" dur="1" fill="hold">
-                                          <p:stCondLst>
-                                            <p:cond delay="0"/>
-                                          </p:stCondLst>
-                                        </p:cTn>
-                                        <p:tgtEl>
-                                          <p:spTgt spid="24"/>
-                                        </p:tgtEl>
-                                        <p:attrNameLst>
-                                          <p:attrName>style.visibility</p:attrName>
-                                        </p:attrNameLst>
-                                      </p:cBhvr>
-                                      <p:to>
-                                        <p:strVal val="visible"/>
-                                      </p:to>
-                                    </p:set>
-                                    <p:animEffect transition="in" filter="fade">
-                                      <p:cBhvr>
-                                        <p:cTn id="71" dur="500"/>
-                                        <p:tgtEl>
-                                          <p:spTgt spid="24"/>
-                                        </p:tgtEl>
-                                      </p:cBhvr>
-                                    </p:animEffect>
-                                  </p:childTnLst>
-                                </p:cTn>
-                              </p:par>
-                              <p:par>
-                                <p:cTn id="72" presetID="10" presetClass="entr" presetSubtype="0" fill="hold" grpId="0" nodeType="withEffect">
-                                  <p:stCondLst>
-                                    <p:cond delay="0"/>
-                                  </p:stCondLst>
-                                  <p:childTnLst>
-                                    <p:set>
-                                      <p:cBhvr>
-                                        <p:cTn id="73" dur="1" fill="hold">
-                                          <p:stCondLst>
-                                            <p:cond delay="0"/>
-                                          </p:stCondLst>
-                                        </p:cTn>
-                                        <p:tgtEl>
-                                          <p:spTgt spid="25"/>
-                                        </p:tgtEl>
-                                        <p:attrNameLst>
-                                          <p:attrName>style.visibility</p:attrName>
-                                        </p:attrNameLst>
-                                      </p:cBhvr>
-                                      <p:to>
-                                        <p:strVal val="visible"/>
-                                      </p:to>
-                                    </p:set>
-                                    <p:animEffect transition="in" filter="fade">
-                                      <p:cBhvr>
-                                        <p:cTn id="74" dur="500"/>
-                                        <p:tgtEl>
-                                          <p:spTgt spid="25"/>
+                                <p:cTn id="18" presetID="10" presetClass="entr" presetSubtype="0" fill="hold" grpId="0" nodeType="afterEffect">
+                                  <p:stCondLst>
+                                    <p:cond delay="0"/>
+                                  </p:stCondLst>
+                                  <p:childTnLst>
+                                    <p:set>
+                                      <p:cBhvr>
+                                        <p:cTn id="19" dur="1" fill="hold">
+                                          <p:stCondLst>
+                                            <p:cond delay="0"/>
+                                          </p:stCondLst>
+                                        </p:cTn>
+                                        <p:tgtEl>
+                                          <p:spTgt spid="7"/>
+                                        </p:tgtEl>
+                                        <p:attrNameLst>
+                                          <p:attrName>style.visibility</p:attrName>
+                                        </p:attrNameLst>
+                                      </p:cBhvr>
+                                      <p:to>
+                                        <p:strVal val="visible"/>
+                                      </p:to>
+                                    </p:set>
+                                    <p:animEffect transition="in" filter="fade">
+                                      <p:cBhvr>
+                                        <p:cTn id="20" dur="500"/>
+                                        <p:tgtEl>
+                                          <p:spTgt spid="7"/>
+                                        </p:tgtEl>
+                                      </p:cBhvr>
+                                    </p:animEffect>
+                                  </p:childTnLst>
+                                </p:cTn>
+                              </p:par>
+                              <p:par>
+                                <p:cTn id="21" presetID="10" presetClass="entr" presetSubtype="0" fill="hold" grpId="0" nodeType="withEffect">
+                                  <p:stCondLst>
+                                    <p:cond delay="0"/>
+                                  </p:stCondLst>
+                                  <p:childTnLst>
+                                    <p:set>
+                                      <p:cBhvr>
+                                        <p:cTn id="22" dur="1" fill="hold">
+                                          <p:stCondLst>
+                                            <p:cond delay="0"/>
+                                          </p:stCondLst>
+                                        </p:cTn>
+                                        <p:tgtEl>
+                                          <p:spTgt spid="8"/>
+                                        </p:tgtEl>
+                                        <p:attrNameLst>
+                                          <p:attrName>style.visibility</p:attrName>
+                                        </p:attrNameLst>
+                                      </p:cBhvr>
+                                      <p:to>
+                                        <p:strVal val="visible"/>
+                                      </p:to>
+                                    </p:set>
+                                    <p:animEffect transition="in" filter="fade">
+                                      <p:cBhvr>
+                                        <p:cTn id="23" dur="500"/>
+                                        <p:tgtEl>
+                                          <p:spTgt spid="8"/>
+                                        </p:tgtEl>
+                                      </p:cBhvr>
+                                    </p:animEffect>
+                                  </p:childTnLst>
+                                </p:cTn>
+                              </p:par>
+                              <p:par>
+                                <p:cTn id="24" presetID="10" presetClass="entr" presetSubtype="0" fill="hold" grpId="0" nodeType="withEffect">
+                                  <p:stCondLst>
+                                    <p:cond delay="0"/>
+                                  </p:stCondLst>
+                                  <p:childTnLst>
+                                    <p:set>
+                                      <p:cBhvr>
+                                        <p:cTn id="25" dur="1" fill="hold">
+                                          <p:stCondLst>
+                                            <p:cond delay="0"/>
+                                          </p:stCondLst>
+                                        </p:cTn>
+                                        <p:tgtEl>
+                                          <p:spTgt spid="9"/>
+                                        </p:tgtEl>
+                                        <p:attrNameLst>
+                                          <p:attrName>style.visibility</p:attrName>
+                                        </p:attrNameLst>
+                                      </p:cBhvr>
+                                      <p:to>
+                                        <p:strVal val="visible"/>
+                                      </p:to>
+                                    </p:set>
+                                    <p:animEffect transition="in" filter="fade">
+                                      <p:cBhvr>
+                                        <p:cTn id="26" dur="500"/>
+                                        <p:tgtEl>
+                                          <p:spTgt spid="9"/>
                                         </p:tgtEl>
                                       </p:cBhvr>
                                     </p:animEffect>
@@ -25355,145 +26380,478 @@
                           </p:cTn>
                         </p:par>
                         <p:par>
-                          <p:cTn id="88" fill="hold">
+                          <p:cTn id="37" fill="hold">
                             <p:stCondLst>
                               <p:cond delay="1650"/>
                             </p:stCondLst>
                             <p:childTnLst>
                               <p:par>
-                                <p:cTn id="76" presetID="10" presetClass="entr" presetSubtype="0" fill="hold" grpId="0" nodeType="afterEffect">
-                                  <p:stCondLst>
-                                    <p:cond delay="0"/>
-                                  </p:stCondLst>
-                                  <p:childTnLst>
-                                    <p:set>
-                                      <p:cBhvr>
-                                        <p:cTn id="77" dur="1" fill="hold">
-                                          <p:stCondLst>
-                                            <p:cond delay="0"/>
-                                          </p:stCondLst>
-                                        </p:cTn>
-                                        <p:tgtEl>
-                                          <p:spTgt spid="26"/>
-                                        </p:tgtEl>
-                                        <p:attrNameLst>
-                                          <p:attrName>style.visibility</p:attrName>
-                                        </p:attrNameLst>
-                                      </p:cBhvr>
-                                      <p:to>
-                                        <p:strVal val="visible"/>
-                                      </p:to>
-                                    </p:set>
-                                    <p:animEffect transition="in" filter="fade">
-                                      <p:cBhvr>
-                                        <p:cTn id="78" dur="500"/>
-                                        <p:tgtEl>
-                                          <p:spTgt spid="26"/>
-                                        </p:tgtEl>
-                                      </p:cBhvr>
-                                    </p:animEffect>
-                                  </p:childTnLst>
-                                </p:cTn>
-                              </p:par>
-                              <p:par>
-                                <p:cTn id="79" presetID="10" presetClass="entr" presetSubtype="0" fill="hold" grpId="0" nodeType="withEffect">
-                                  <p:stCondLst>
-                                    <p:cond delay="0"/>
-                                  </p:stCondLst>
-                                  <p:childTnLst>
-                                    <p:set>
-                                      <p:cBhvr>
-                                        <p:cTn id="80" dur="1" fill="hold">
-                                          <p:stCondLst>
-                                            <p:cond delay="0"/>
-                                          </p:stCondLst>
-                                        </p:cTn>
-                                        <p:tgtEl>
-                                          <p:spTgt spid="27"/>
-                                        </p:tgtEl>
-                                        <p:attrNameLst>
-                                          <p:attrName>style.visibility</p:attrName>
-                                        </p:attrNameLst>
-                                      </p:cBhvr>
-                                      <p:to>
-                                        <p:strVal val="visible"/>
-                                      </p:to>
-                                    </p:set>
-                                    <p:animEffect transition="in" filter="fade">
-                                      <p:cBhvr>
-                                        <p:cTn id="81" dur="500"/>
-                                        <p:tgtEl>
-                                          <p:spTgt spid="27"/>
-                                        </p:tgtEl>
-                                      </p:cBhvr>
-                                    </p:animEffect>
-                                  </p:childTnLst>
-                                </p:cTn>
-                              </p:par>
-                              <p:par>
-                                <p:cTn id="82" presetID="10" presetClass="entr" presetSubtype="0" fill="hold" grpId="0" nodeType="withEffect">
-                                  <p:stCondLst>
-                                    <p:cond delay="0"/>
-                                  </p:stCondLst>
-                                  <p:childTnLst>
-                                    <p:set>
-                                      <p:cBhvr>
-                                        <p:cTn id="83" dur="1" fill="hold">
-                                          <p:stCondLst>
-                                            <p:cond delay="0"/>
-                                          </p:stCondLst>
-                                        </p:cTn>
-                                        <p:tgtEl>
-                                          <p:spTgt spid="28"/>
-                                        </p:tgtEl>
-                                        <p:attrNameLst>
-                                          <p:attrName>style.visibility</p:attrName>
-                                        </p:attrNameLst>
-                                      </p:cBhvr>
-                                      <p:to>
-                                        <p:strVal val="visible"/>
-                                      </p:to>
-                                    </p:set>
-                                    <p:animEffect transition="in" filter="fade">
-                                      <p:cBhvr>
-                                        <p:cTn id="84" dur="500"/>
-                                        <p:tgtEl>
-                                          <p:spTgt spid="28"/>
-                                        </p:tgtEl>
-                                      </p:cBhvr>
-                                    </p:animEffect>
-                                  </p:childTnLst>
-                                </p:cTn>
-                              </p:par>
-                              <p:par>
-                                <p:cTn id="85" presetID="10" presetClass="entr" presetSubtype="0" fill="hold" grpId="0" nodeType="withEffect">
-                                  <p:stCondLst>
-                                    <p:cond delay="0"/>
-                                  </p:stCondLst>
-                                  <p:childTnLst>
-                                    <p:set>
-                                      <p:cBhvr>
-                                        <p:cTn id="86" dur="1" fill="hold">
-                                          <p:stCondLst>
-                                            <p:cond delay="0"/>
-                                          </p:stCondLst>
-                                        </p:cTn>
-                                        <p:tgtEl>
-                                          <p:spTgt spid="29"/>
-                                        </p:tgtEl>
-                                        <p:attrNameLst>
-                                          <p:attrName>style.visibility</p:attrName>
-                                        </p:attrNameLst>
-                                      </p:cBhvr>
-                                      <p:to>
-                                        <p:strVal val="visible"/>
-                                      </p:to>
-                                    </p:set>
-                                    <p:animEffect transition="in" filter="fade">
-                                      <p:cBhvr>
-                                        <p:cTn id="87" dur="500"/>
-                                        <p:tgtEl>
-                                          <p:spTgt spid="29"/>
+                                <p:cTn id="28" presetID="10" presetClass="entr" presetSubtype="0" fill="hold" grpId="0" nodeType="afterEffect">
+                                  <p:stCondLst>
+                                    <p:cond delay="0"/>
+                                  </p:stCondLst>
+                                  <p:childTnLst>
+                                    <p:set>
+                                      <p:cBhvr>
+                                        <p:cTn id="29" dur="1" fill="hold">
+                                          <p:stCondLst>
+                                            <p:cond delay="0"/>
+                                          </p:stCondLst>
+                                        </p:cTn>
+                                        <p:tgtEl>
+                                          <p:spTgt spid="10"/>
+                                        </p:tgtEl>
+                                        <p:attrNameLst>
+                                          <p:attrName>style.visibility</p:attrName>
+                                        </p:attrNameLst>
+                                      </p:cBhvr>
+                                      <p:to>
+                                        <p:strVal val="visible"/>
+                                      </p:to>
+                                    </p:set>
+                                    <p:animEffect transition="in" filter="fade">
+                                      <p:cBhvr>
+                                        <p:cTn id="30" dur="500"/>
+                                        <p:tgtEl>
+                                          <p:spTgt spid="10"/>
+                                        </p:tgtEl>
+                                      </p:cBhvr>
+                                    </p:animEffect>
+                                  </p:childTnLst>
+                                </p:cTn>
+                              </p:par>
+                              <p:par>
+                                <p:cTn id="31" presetID="10" presetClass="entr" presetSubtype="0" fill="hold" grpId="0" nodeType="withEffect">
+                                  <p:stCondLst>
+                                    <p:cond delay="0"/>
+                                  </p:stCondLst>
+                                  <p:childTnLst>
+                                    <p:set>
+                                      <p:cBhvr>
+                                        <p:cTn id="32" dur="1" fill="hold">
+                                          <p:stCondLst>
+                                            <p:cond delay="0"/>
+                                          </p:stCondLst>
+                                        </p:cTn>
+                                        <p:tgtEl>
+                                          <p:spTgt spid="11"/>
+                                        </p:tgtEl>
+                                        <p:attrNameLst>
+                                          <p:attrName>style.visibility</p:attrName>
+                                        </p:attrNameLst>
+                                      </p:cBhvr>
+                                      <p:to>
+                                        <p:strVal val="visible"/>
+                                      </p:to>
+                                    </p:set>
+                                    <p:animEffect transition="in" filter="fade">
+                                      <p:cBhvr>
+                                        <p:cTn id="33" dur="500"/>
+                                        <p:tgtEl>
+                                          <p:spTgt spid="11"/>
+                                        </p:tgtEl>
+                                      </p:cBhvr>
+                                    </p:animEffect>
+                                  </p:childTnLst>
+                                </p:cTn>
+                              </p:par>
+                              <p:par>
+                                <p:cTn id="34" presetID="10" presetClass="entr" presetSubtype="0" fill="hold" grpId="0" nodeType="withEffect">
+                                  <p:stCondLst>
+                                    <p:cond delay="0"/>
+                                  </p:stCondLst>
+                                  <p:childTnLst>
+                                    <p:set>
+                                      <p:cBhvr>
+                                        <p:cTn id="35" dur="1" fill="hold">
+                                          <p:stCondLst>
+                                            <p:cond delay="0"/>
+                                          </p:stCondLst>
+                                        </p:cTn>
+                                        <p:tgtEl>
+                                          <p:spTgt spid="12"/>
+                                        </p:tgtEl>
+                                        <p:attrNameLst>
+                                          <p:attrName>style.visibility</p:attrName>
+                                        </p:attrNameLst>
+                                      </p:cBhvr>
+                                      <p:to>
+                                        <p:strVal val="visible"/>
+                                      </p:to>
+                                    </p:set>
+                                    <p:animEffect transition="in" filter="fade">
+                                      <p:cBhvr>
+                                        <p:cTn id="36" dur="500"/>
+                                        <p:tgtEl>
+                                          <p:spTgt spid="12"/>
+                                        </p:tgtEl>
+                                      </p:cBhvr>
+                                    </p:animEffect>
+                                  </p:childTnLst>
+                                </p:cTn>
+                              </p:par>
+                            </p:childTnLst>
+                          </p:cTn>
+                        </p:par>
+                        <p:par>
+                          <p:cTn id="47" fill="hold">
+                            <p:stCondLst>
+                              <p:cond delay="2100"/>
+                            </p:stCondLst>
+                            <p:childTnLst>
+                              <p:par>
+                                <p:cTn id="38" presetID="10" presetClass="entr" presetSubtype="0" fill="hold" grpId="0" nodeType="afterEffect">
+                                  <p:stCondLst>
+                                    <p:cond delay="0"/>
+                                  </p:stCondLst>
+                                  <p:childTnLst>
+                                    <p:set>
+                                      <p:cBhvr>
+                                        <p:cTn id="39" dur="1" fill="hold">
+                                          <p:stCondLst>
+                                            <p:cond delay="0"/>
+                                          </p:stCondLst>
+                                        </p:cTn>
+                                        <p:tgtEl>
+                                          <p:spTgt spid="13"/>
+                                        </p:tgtEl>
+                                        <p:attrNameLst>
+                                          <p:attrName>style.visibility</p:attrName>
+                                        </p:attrNameLst>
+                                      </p:cBhvr>
+                                      <p:to>
+                                        <p:strVal val="visible"/>
+                                      </p:to>
+                                    </p:set>
+                                    <p:animEffect transition="in" filter="fade">
+                                      <p:cBhvr>
+                                        <p:cTn id="40" dur="500"/>
+                                        <p:tgtEl>
+                                          <p:spTgt spid="13"/>
+                                        </p:tgtEl>
+                                      </p:cBhvr>
+                                    </p:animEffect>
+                                  </p:childTnLst>
+                                </p:cTn>
+                              </p:par>
+                              <p:par>
+                                <p:cTn id="41" presetID="10" presetClass="entr" presetSubtype="0" fill="hold" grpId="0" nodeType="withEffect">
+                                  <p:stCondLst>
+                                    <p:cond delay="0"/>
+                                  </p:stCondLst>
+                                  <p:childTnLst>
+                                    <p:set>
+                                      <p:cBhvr>
+                                        <p:cTn id="42" dur="1" fill="hold">
+                                          <p:stCondLst>
+                                            <p:cond delay="0"/>
+                                          </p:stCondLst>
+                                        </p:cTn>
+                                        <p:tgtEl>
+                                          <p:spTgt spid="14"/>
+                                        </p:tgtEl>
+                                        <p:attrNameLst>
+                                          <p:attrName>style.visibility</p:attrName>
+                                        </p:attrNameLst>
+                                      </p:cBhvr>
+                                      <p:to>
+                                        <p:strVal val="visible"/>
+                                      </p:to>
+                                    </p:set>
+                                    <p:animEffect transition="in" filter="fade">
+                                      <p:cBhvr>
+                                        <p:cTn id="43" dur="500"/>
+                                        <p:tgtEl>
+                                          <p:spTgt spid="14"/>
+                                        </p:tgtEl>
+                                      </p:cBhvr>
+                                    </p:animEffect>
+                                  </p:childTnLst>
+                                </p:cTn>
+                              </p:par>
+                              <p:par>
+                                <p:cTn id="44" presetID="10" presetClass="entr" presetSubtype="0" fill="hold" grpId="0" nodeType="withEffect">
+                                  <p:stCondLst>
+                                    <p:cond delay="0"/>
+                                  </p:stCondLst>
+                                  <p:childTnLst>
+                                    <p:set>
+                                      <p:cBhvr>
+                                        <p:cTn id="45" dur="1" fill="hold">
+                                          <p:stCondLst>
+                                            <p:cond delay="0"/>
+                                          </p:stCondLst>
+                                        </p:cTn>
+                                        <p:tgtEl>
+                                          <p:spTgt spid="15"/>
+                                        </p:tgtEl>
+                                        <p:attrNameLst>
+                                          <p:attrName>style.visibility</p:attrName>
+                                        </p:attrNameLst>
+                                      </p:cBhvr>
+                                      <p:to>
+                                        <p:strVal val="visible"/>
+                                      </p:to>
+                                    </p:set>
+                                    <p:animEffect transition="in" filter="fade">
+                                      <p:cBhvr>
+                                        <p:cTn id="46" dur="500"/>
+                                        <p:tgtEl>
+                                          <p:spTgt spid="15"/>
+                                        </p:tgtEl>
+                                      </p:cBhvr>
+                                    </p:animEffect>
+                                  </p:childTnLst>
+                                </p:cTn>
+                              </p:par>
+                            </p:childTnLst>
+                          </p:cTn>
+                        </p:par>
+                        <p:par>
+                          <p:cTn id="69" fill="hold">
+                            <p:stCondLst>
+                              <p:cond delay="2550"/>
+                            </p:stCondLst>
+                            <p:childTnLst>
+                              <p:par>
+                                <p:cTn id="48" presetID="10" presetClass="entr" presetSubtype="0" fill="hold" grpId="0" nodeType="afterEffect">
+                                  <p:stCondLst>
+                                    <p:cond delay="0"/>
+                                  </p:stCondLst>
+                                  <p:childTnLst>
+                                    <p:set>
+                                      <p:cBhvr>
+                                        <p:cTn id="49" dur="1" fill="hold">
+                                          <p:stCondLst>
+                                            <p:cond delay="0"/>
+                                          </p:stCondLst>
+                                        </p:cTn>
+                                        <p:tgtEl>
+                                          <p:spTgt spid="16"/>
+                                        </p:tgtEl>
+                                        <p:attrNameLst>
+                                          <p:attrName>style.visibility</p:attrName>
+                                        </p:attrNameLst>
+                                      </p:cBhvr>
+                                      <p:to>
+                                        <p:strVal val="visible"/>
+                                      </p:to>
+                                    </p:set>
+                                    <p:animEffect transition="in" filter="fade">
+                                      <p:cBhvr>
+                                        <p:cTn id="50" dur="500"/>
+                                        <p:tgtEl>
+                                          <p:spTgt spid="16"/>
+                                        </p:tgtEl>
+                                      </p:cBhvr>
+                                    </p:animEffect>
+                                  </p:childTnLst>
+                                </p:cTn>
+                              </p:par>
+                              <p:par>
+                                <p:cTn id="51" presetID="10" presetClass="entr" presetSubtype="0" fill="hold" grpId="0" nodeType="withEffect">
+                                  <p:stCondLst>
+                                    <p:cond delay="0"/>
+                                  </p:stCondLst>
+                                  <p:childTnLst>
+                                    <p:set>
+                                      <p:cBhvr>
+                                        <p:cTn id="52" dur="1" fill="hold">
+                                          <p:stCondLst>
+                                            <p:cond delay="0"/>
+                                          </p:stCondLst>
+                                        </p:cTn>
+                                        <p:tgtEl>
+                                          <p:spTgt spid="17"/>
+                                        </p:tgtEl>
+                                        <p:attrNameLst>
+                                          <p:attrName>style.visibility</p:attrName>
+                                        </p:attrNameLst>
+                                      </p:cBhvr>
+                                      <p:to>
+                                        <p:strVal val="visible"/>
+                                      </p:to>
+                                    </p:set>
+                                    <p:animEffect transition="in" filter="fade">
+                                      <p:cBhvr>
+                                        <p:cTn id="53" dur="500"/>
+                                        <p:tgtEl>
+                                          <p:spTgt spid="17"/>
+                                        </p:tgtEl>
+                                      </p:cBhvr>
+                                    </p:animEffect>
+                                  </p:childTnLst>
+                                </p:cTn>
+                              </p:par>
+                              <p:par>
+                                <p:cTn id="54" presetID="10" presetClass="entr" presetSubtype="0" fill="hold" grpId="0" nodeType="withEffect">
+                                  <p:stCondLst>
+                                    <p:cond delay="0"/>
+                                  </p:stCondLst>
+                                  <p:childTnLst>
+                                    <p:set>
+                                      <p:cBhvr>
+                                        <p:cTn id="55" dur="1" fill="hold">
+                                          <p:stCondLst>
+                                            <p:cond delay="0"/>
+                                          </p:stCondLst>
+                                        </p:cTn>
+                                        <p:tgtEl>
+                                          <p:spTgt spid="18"/>
+                                        </p:tgtEl>
+                                        <p:attrNameLst>
+                                          <p:attrName>style.visibility</p:attrName>
+                                        </p:attrNameLst>
+                                      </p:cBhvr>
+                                      <p:to>
+                                        <p:strVal val="visible"/>
+                                      </p:to>
+                                    </p:set>
+                                    <p:animEffect transition="in" filter="fade">
+                                      <p:cBhvr>
+                                        <p:cTn id="56" dur="500"/>
+                                        <p:tgtEl>
+                                          <p:spTgt spid="18"/>
+                                        </p:tgtEl>
+                                      </p:cBhvr>
+                                    </p:animEffect>
+                                  </p:childTnLst>
+                                </p:cTn>
+                              </p:par>
+                              <p:par>
+                                <p:cTn id="57" presetID="10" presetClass="entr" presetSubtype="0" fill="hold" grpId="0" nodeType="withEffect">
+                                  <p:stCondLst>
+                                    <p:cond delay="0"/>
+                                  </p:stCondLst>
+                                  <p:childTnLst>
+                                    <p:set>
+                                      <p:cBhvr>
+                                        <p:cTn id="58" dur="1" fill="hold">
+                                          <p:stCondLst>
+                                            <p:cond delay="0"/>
+                                          </p:stCondLst>
+                                        </p:cTn>
+                                        <p:tgtEl>
+                                          <p:spTgt spid="19"/>
+                                        </p:tgtEl>
+                                        <p:attrNameLst>
+                                          <p:attrName>style.visibility</p:attrName>
+                                        </p:attrNameLst>
+                                      </p:cBhvr>
+                                      <p:to>
+                                        <p:strVal val="visible"/>
+                                      </p:to>
+                                    </p:set>
+                                    <p:animEffect transition="in" filter="fade">
+                                      <p:cBhvr>
+                                        <p:cTn id="59" dur="500"/>
+                                        <p:tgtEl>
+                                          <p:spTgt spid="19"/>
+                                        </p:tgtEl>
+                                      </p:cBhvr>
+                                    </p:animEffect>
+                                  </p:childTnLst>
+                                </p:cTn>
+                              </p:par>
+                              <p:par>
+                                <p:cTn id="60" presetID="10" presetClass="entr" presetSubtype="0" fill="hold" grpId="0" nodeType="withEffect">
+                                  <p:stCondLst>
+                                    <p:cond delay="0"/>
+                                  </p:stCondLst>
+                                  <p:childTnLst>
+                                    <p:set>
+                                      <p:cBhvr>
+                                        <p:cTn id="61" dur="1" fill="hold">
+                                          <p:stCondLst>
+                                            <p:cond delay="0"/>
+                                          </p:stCondLst>
+                                        </p:cTn>
+                                        <p:tgtEl>
+                                          <p:spTgt spid="20"/>
+                                        </p:tgtEl>
+                                        <p:attrNameLst>
+                                          <p:attrName>style.visibility</p:attrName>
+                                        </p:attrNameLst>
+                                      </p:cBhvr>
+                                      <p:to>
+                                        <p:strVal val="visible"/>
+                                      </p:to>
+                                    </p:set>
+                                    <p:animEffect transition="in" filter="fade">
+                                      <p:cBhvr>
+                                        <p:cTn id="62" dur="500"/>
+                                        <p:tgtEl>
+                                          <p:spTgt spid="20"/>
+                                        </p:tgtEl>
+                                      </p:cBhvr>
+                                    </p:animEffect>
+                                  </p:childTnLst>
+                                </p:cTn>
+                              </p:par>
+                              <p:par>
+                                <p:cTn id="63" presetID="10" presetClass="entr" presetSubtype="0" fill="hold" grpId="0" nodeType="withEffect">
+                                  <p:stCondLst>
+                                    <p:cond delay="0"/>
+                                  </p:stCondLst>
+                                  <p:childTnLst>
+                                    <p:set>
+                                      <p:cBhvr>
+                                        <p:cTn id="64" dur="1" fill="hold">
+                                          <p:stCondLst>
+                                            <p:cond delay="0"/>
+                                          </p:stCondLst>
+                                        </p:cTn>
+                                        <p:tgtEl>
+                                          <p:spTgt spid="21"/>
+                                        </p:tgtEl>
+                                        <p:attrNameLst>
+                                          <p:attrName>style.visibility</p:attrName>
+                                        </p:attrNameLst>
+                                      </p:cBhvr>
+                                      <p:to>
+                                        <p:strVal val="visible"/>
+                                      </p:to>
+                                    </p:set>
+                                    <p:animEffect transition="in" filter="fade">
+                                      <p:cBhvr>
+                                        <p:cTn id="65" dur="500"/>
+                                        <p:tgtEl>
+                                          <p:spTgt spid="21"/>
+                                        </p:tgtEl>
+                                      </p:cBhvr>
+                                    </p:animEffect>
+                                  </p:childTnLst>
+                                </p:cTn>
+                              </p:par>
+                              <p:par>
+                                <p:cTn id="66" presetID="10" presetClass="entr" presetSubtype="0" fill="hold" grpId="0" nodeType="withEffect">
+                                  <p:stCondLst>
+                                    <p:cond delay="0"/>
+                                  </p:stCondLst>
+                                  <p:childTnLst>
+                                    <p:set>
+                                      <p:cBhvr>
+                                        <p:cTn id="67" dur="1" fill="hold">
+                                          <p:stCondLst>
+                                            <p:cond delay="0"/>
+                                          </p:stCondLst>
+                                        </p:cTn>
+                                        <p:tgtEl>
+                                          <p:spTgt spid="22"/>
+                                        </p:tgtEl>
+                                        <p:attrNameLst>
+                                          <p:attrName>style.visibility</p:attrName>
+                                        </p:attrNameLst>
+                                      </p:cBhvr>
+                                      <p:to>
+                                        <p:strVal val="visible"/>
+                                      </p:to>
+                                    </p:set>
+                                    <p:animEffect transition="in" filter="fade">
+                                      <p:cBhvr>
+                                        <p:cTn id="68" dur="500"/>
+                                        <p:tgtEl>
+                                          <p:spTgt spid="22"/>
                                         </p:tgtEl>
                                       </p:cBhvr>
                                     </p:animEffect>
@@ -25530,22 +26888,21 @@
     <p:bldLst>
       <p:bldP spid="3" grpId="0" animBg="1"/>
       <p:bldP spid="4" grpId="0" animBg="1"/>
-      <p:bldP spid="5" grpId="0" animBg="1"/>
+      <p:bldP spid="6" grpId="0" animBg="1"/>
       <p:bldP spid="7" grpId="0" animBg="1"/>
-      <p:bldP spid="8" grpId="0" animBg="1"/>
+      <p:bldP spid="9" grpId="0" animBg="1"/>
       <p:bldP spid="10" grpId="0" animBg="1"/>
       <p:bldP spid="12" grpId="0" animBg="1"/>
+      <p:bldP spid="13" grpId="0" animBg="1"/>
       <p:bldP spid="14" grpId="0" animBg="1"/>
       <p:bldP spid="15" grpId="0" animBg="1"/>
       <p:bldP spid="16" grpId="0" animBg="1"/>
+      <p:bldP spid="17" grpId="0" animBg="1"/>
       <p:bldP spid="18" grpId="0" animBg="1"/>
       <p:bldP spid="19" grpId="0" animBg="1"/>
+      <p:bldP spid="20" grpId="0" animBg="1"/>
       <p:bldP spid="21" grpId="0" animBg="1"/>
-      <p:bldP spid="23" grpId="0" animBg="1"/>
-      <p:bldP spid="25" grpId="0" animBg="1"/>
-      <p:bldP spid="26" grpId="0" animBg="1"/>
-      <p:bldP spid="27" grpId="0" animBg="1"/>
-      <p:bldP spid="29" grpId="0" animBg="1"/>
+      <p:bldP spid="22" grpId="0" animBg="1"/>
     </p:bldLst>
   </p:timing>
 </p:sld>

</xml_diff>